<commit_message>
BERT-Attack: Adversarial Attack Against BERT Using BERT
</commit_message>
<xml_diff>
--- a/Attack/Adversarial_Attack/CV/论文作图.pptx
+++ b/Attack/Adversarial_Attack/CV/论文作图.pptx
@@ -8,10 +8,13 @@
     <p:notesMasterId r:id="rId4"/>
   </p:notesMasterIdLst>
   <p:handoutMasterIdLst>
-    <p:handoutMasterId r:id="rId5"/>
+    <p:handoutMasterId r:id="rId8"/>
   </p:handoutMasterIdLst>
   <p:sldIdLst>
     <p:sldId id="256" r:id="rId3"/>
+    <p:sldId id="257" r:id="rId5"/>
+    <p:sldId id="258" r:id="rId6"/>
+    <p:sldId id="259" r:id="rId7"/>
   </p:sldIdLst>
   <p:sldSz cx="12192000" cy="6858000"/>
   <p:notesSz cx="7103745" cy="10234295"/>
@@ -3531,7 +3534,13 @@
           <a:bodyPr/>
           <a:lstStyle/>
           <a:p>
-            <a:endParaRPr lang="zh-CN" altLang="en-US" dirty="0">
+            <a:r>
+              <a:rPr lang="en-US" altLang="zh-CN" dirty="0">
+                <a:effectLst/>
+              </a:rPr>
+              <a:t>FGSM</a:t>
+            </a:r>
+            <a:endParaRPr lang="en-US" altLang="zh-CN" dirty="0">
               <a:effectLst/>
             </a:endParaRPr>
           </a:p>
@@ -3564,6 +3573,4027 @@
     <a:masterClrMapping/>
   </p:clrMapOvr>
 </p:sld>
+</file>
+
+<file path=ppt/slides/slide2.xml><?xml version="1.0" encoding="utf-8"?>
+<p:sld xmlns:a="http://schemas.openxmlformats.org/drawingml/2006/main" xmlns:r="http://schemas.openxmlformats.org/officeDocument/2006/relationships" xmlns:p="http://schemas.openxmlformats.org/presentationml/2006/main">
+  <p:cSld>
+    <p:spTree>
+      <p:nvGrpSpPr>
+        <p:cNvPr id="1" name=""/>
+        <p:cNvGrpSpPr/>
+        <p:nvPr/>
+      </p:nvGrpSpPr>
+      <p:grpSpPr/>
+      <p:pic>
+        <p:nvPicPr>
+          <p:cNvPr id="20" name="图片 19"/>
+          <p:cNvPicPr>
+            <a:picLocks noChangeAspect="1"/>
+          </p:cNvPicPr>
+          <p:nvPr>
+            <p:custDataLst>
+              <p:tags r:id="rId1"/>
+            </p:custDataLst>
+          </p:nvPr>
+        </p:nvPicPr>
+        <p:blipFill>
+          <a:blip r:embed="rId2"/>
+          <a:stretch>
+            <a:fillRect/>
+          </a:stretch>
+        </p:blipFill>
+        <p:spPr>
+          <a:xfrm>
+            <a:off x="6040120" y="4767580"/>
+            <a:ext cx="587375" cy="1043940"/>
+          </a:xfrm>
+          <a:prstGeom prst="rect">
+            <a:avLst/>
+          </a:prstGeom>
+        </p:spPr>
+      </p:pic>
+      <p:sp>
+        <p:nvSpPr>
+          <p:cNvPr id="16" name="下箭头 15"/>
+          <p:cNvSpPr/>
+          <p:nvPr/>
+        </p:nvSpPr>
+        <p:spPr>
+          <a:xfrm>
+            <a:off x="8147050" y="2530475"/>
+            <a:ext cx="607060" cy="1546225"/>
+          </a:xfrm>
+          <a:prstGeom prst="downArrow">
+            <a:avLst/>
+          </a:prstGeom>
+        </p:spPr>
+        <p:style>
+          <a:lnRef idx="2">
+            <a:schemeClr val="accent1">
+              <a:lumMod val="75000"/>
+            </a:schemeClr>
+          </a:lnRef>
+          <a:fillRef idx="1">
+            <a:schemeClr val="accent1"/>
+          </a:fillRef>
+          <a:effectRef idx="0">
+            <a:srgbClr val="FFFFFF"/>
+          </a:effectRef>
+          <a:fontRef idx="minor">
+            <a:schemeClr val="lt1"/>
+          </a:fontRef>
+        </p:style>
+        <p:txBody>
+          <a:bodyPr rtlCol="0" anchor="ctr"/>
+          <a:p>
+            <a:pPr algn="ctr"/>
+            <a:endParaRPr lang="zh-CN" altLang="en-US"/>
+          </a:p>
+        </p:txBody>
+      </p:sp>
+      <p:sp>
+        <p:nvSpPr>
+          <p:cNvPr id="5" name="矩形 4"/>
+          <p:cNvSpPr/>
+          <p:nvPr/>
+        </p:nvSpPr>
+        <p:spPr>
+          <a:xfrm>
+            <a:off x="2854325" y="631190"/>
+            <a:ext cx="3580130" cy="4293870"/>
+          </a:xfrm>
+          <a:prstGeom prst="rect">
+            <a:avLst/>
+          </a:prstGeom>
+          <a:solidFill>
+            <a:srgbClr val="797979"/>
+          </a:solidFill>
+        </p:spPr>
+        <p:style>
+          <a:lnRef idx="2">
+            <a:schemeClr val="accent1">
+              <a:lumMod val="75000"/>
+            </a:schemeClr>
+          </a:lnRef>
+          <a:fillRef idx="1">
+            <a:schemeClr val="accent1"/>
+          </a:fillRef>
+          <a:effectRef idx="0">
+            <a:srgbClr val="FFFFFF"/>
+          </a:effectRef>
+          <a:fontRef idx="minor">
+            <a:schemeClr val="lt1"/>
+          </a:fontRef>
+        </p:style>
+        <p:txBody>
+          <a:bodyPr rtlCol="0" anchor="ctr"/>
+          <a:p>
+            <a:pPr algn="ctr"/>
+            <a:endParaRPr lang="zh-CN" altLang="en-US"/>
+          </a:p>
+        </p:txBody>
+      </p:sp>
+      <p:pic>
+        <p:nvPicPr>
+          <p:cNvPr id="4" name="图片 3"/>
+          <p:cNvPicPr>
+            <a:picLocks noChangeAspect="1"/>
+          </p:cNvPicPr>
+          <p:nvPr>
+            <p:custDataLst>
+              <p:tags r:id="rId3"/>
+            </p:custDataLst>
+          </p:nvPr>
+        </p:nvPicPr>
+        <p:blipFill>
+          <a:blip r:embed="rId4"/>
+          <a:stretch>
+            <a:fillRect/>
+          </a:stretch>
+        </p:blipFill>
+        <p:spPr>
+          <a:xfrm>
+            <a:off x="600075" y="1614805"/>
+            <a:ext cx="1689100" cy="1689100"/>
+          </a:xfrm>
+          <a:prstGeom prst="rect">
+            <a:avLst/>
+          </a:prstGeom>
+        </p:spPr>
+      </p:pic>
+      <p:cxnSp>
+        <p:nvCxnSpPr>
+          <p:cNvPr id="516" name="Google Shape;516;p25"/>
+          <p:cNvCxnSpPr>
+            <a:stCxn id="517" idx="6"/>
+            <a:endCxn id="518" idx="2"/>
+          </p:cNvCxnSpPr>
+          <p:nvPr>
+            <p:custDataLst>
+              <p:tags r:id="rId5"/>
+            </p:custDataLst>
+          </p:nvPr>
+        </p:nvCxnSpPr>
+        <p:spPr>
+          <a:xfrm>
+            <a:off x="3592908" y="1109091"/>
+            <a:ext cx="750300" cy="0"/>
+          </a:xfrm>
+          <a:prstGeom prst="straightConnector1">
+            <a:avLst/>
+          </a:prstGeom>
+          <a:noFill/>
+          <a:ln w="9525" cap="flat" cmpd="sng">
+            <a:solidFill>
+              <a:srgbClr val="595959"/>
+            </a:solidFill>
+            <a:prstDash val="solid"/>
+            <a:round/>
+            <a:headEnd type="none" w="med" len="med"/>
+            <a:tailEnd type="triangle" w="med" len="med"/>
+          </a:ln>
+        </p:spPr>
+      </p:cxnSp>
+      <p:sp>
+        <p:nvSpPr>
+          <p:cNvPr id="517" name="Google Shape;517;p25"/>
+          <p:cNvSpPr/>
+          <p:nvPr>
+            <p:custDataLst>
+              <p:tags r:id="rId6"/>
+            </p:custDataLst>
+          </p:nvPr>
+        </p:nvSpPr>
+        <p:spPr>
+          <a:xfrm>
+            <a:off x="2999808" y="803241"/>
+            <a:ext cx="593100" cy="611700"/>
+          </a:xfrm>
+          <a:prstGeom prst="ellipse">
+            <a:avLst/>
+          </a:prstGeom>
+          <a:gradFill>
+            <a:gsLst>
+              <a:gs pos="0">
+                <a:srgbClr val="E0EDBA">
+                  <a:alpha val="79215"/>
+                </a:srgbClr>
+              </a:gs>
+              <a:gs pos="100000">
+                <a:srgbClr val="DE87F1">
+                  <a:alpha val="48235"/>
+                </a:srgbClr>
+              </a:gs>
+            </a:gsLst>
+            <a:lin ang="13500032" scaled="0"/>
+          </a:gradFill>
+          <a:ln w="9525" cap="flat" cmpd="sng">
+            <a:solidFill>
+              <a:srgbClr val="595959"/>
+            </a:solidFill>
+            <a:prstDash val="solid"/>
+            <a:round/>
+            <a:headEnd type="none" w="sm" len="sm"/>
+            <a:tailEnd type="none" w="sm" len="sm"/>
+          </a:ln>
+        </p:spPr>
+        <p:txBody>
+          <a:bodyPr spcFirstLastPara="1" wrap="square" lIns="91425" tIns="91425" rIns="91425" bIns="91425" anchor="ctr" anchorCtr="0">
+            <a:noAutofit/>
+          </a:bodyPr>
+          <a:p>
+            <a:pPr marL="0" lvl="0" indent="0" algn="l" rtl="0">
+              <a:spcBef>
+                <a:spcPts val="0"/>
+              </a:spcBef>
+              <a:spcAft>
+                <a:spcPts val="0"/>
+              </a:spcAft>
+              <a:buClr>
+                <a:srgbClr val="000000"/>
+              </a:buClr>
+              <a:buSzPts val="1100"/>
+              <a:buFont typeface="Arial" panose="020B0704020202020204"/>
+              <a:buNone/>
+            </a:pPr>
+            <a:r>
+              <a:rPr lang="en-GB" sz="1100">
+                <a:solidFill>
+                  <a:srgbClr val="000000"/>
+                </a:solidFill>
+              </a:rPr>
+              <a:t>a</a:t>
+            </a:r>
+            <a:r>
+              <a:rPr lang="en-GB" sz="1100" baseline="30000">
+                <a:solidFill>
+                  <a:srgbClr val="000000"/>
+                </a:solidFill>
+              </a:rPr>
+              <a:t>[1]</a:t>
+            </a:r>
+            <a:r>
+              <a:rPr lang="en-GB" sz="1100" baseline="-25000">
+                <a:solidFill>
+                  <a:srgbClr val="000000"/>
+                </a:solidFill>
+              </a:rPr>
+              <a:t>1</a:t>
+            </a:r>
+            <a:endParaRPr sz="1200" baseline="-25000"/>
+          </a:p>
+        </p:txBody>
+      </p:sp>
+      <p:sp>
+        <p:nvSpPr>
+          <p:cNvPr id="519" name="Google Shape;519;p25"/>
+          <p:cNvSpPr/>
+          <p:nvPr>
+            <p:custDataLst>
+              <p:tags r:id="rId7"/>
+            </p:custDataLst>
+          </p:nvPr>
+        </p:nvSpPr>
+        <p:spPr>
+          <a:xfrm>
+            <a:off x="2999808" y="1614563"/>
+            <a:ext cx="593100" cy="611700"/>
+          </a:xfrm>
+          <a:prstGeom prst="ellipse">
+            <a:avLst/>
+          </a:prstGeom>
+          <a:gradFill>
+            <a:gsLst>
+              <a:gs pos="0">
+                <a:srgbClr val="E0EDBA">
+                  <a:alpha val="79215"/>
+                </a:srgbClr>
+              </a:gs>
+              <a:gs pos="100000">
+                <a:srgbClr val="DE87F1">
+                  <a:alpha val="48235"/>
+                </a:srgbClr>
+              </a:gs>
+            </a:gsLst>
+            <a:lin ang="13500032" scaled="0"/>
+          </a:gradFill>
+          <a:ln w="9525" cap="flat" cmpd="sng">
+            <a:solidFill>
+              <a:srgbClr val="595959"/>
+            </a:solidFill>
+            <a:prstDash val="solid"/>
+            <a:round/>
+            <a:headEnd type="none" w="sm" len="sm"/>
+            <a:tailEnd type="none" w="sm" len="sm"/>
+          </a:ln>
+        </p:spPr>
+        <p:txBody>
+          <a:bodyPr spcFirstLastPara="1" wrap="square" lIns="91425" tIns="91425" rIns="91425" bIns="91425" anchor="ctr" anchorCtr="0">
+            <a:noAutofit/>
+          </a:bodyPr>
+          <a:p>
+            <a:pPr marL="0" lvl="0" indent="0" algn="l" rtl="0">
+              <a:spcBef>
+                <a:spcPts val="0"/>
+              </a:spcBef>
+              <a:spcAft>
+                <a:spcPts val="0"/>
+              </a:spcAft>
+              <a:buClr>
+                <a:srgbClr val="000000"/>
+              </a:buClr>
+              <a:buSzPts val="1100"/>
+              <a:buFont typeface="Arial" panose="020B0704020202020204"/>
+              <a:buNone/>
+            </a:pPr>
+            <a:r>
+              <a:rPr lang="en-GB" sz="1100">
+                <a:solidFill>
+                  <a:srgbClr val="000000"/>
+                </a:solidFill>
+              </a:rPr>
+              <a:t>a</a:t>
+            </a:r>
+            <a:r>
+              <a:rPr lang="en-GB" sz="1100" baseline="30000">
+                <a:solidFill>
+                  <a:srgbClr val="000000"/>
+                </a:solidFill>
+              </a:rPr>
+              <a:t>[1]</a:t>
+            </a:r>
+            <a:r>
+              <a:rPr lang="en-GB" sz="1100" baseline="-25000">
+                <a:solidFill>
+                  <a:srgbClr val="000000"/>
+                </a:solidFill>
+              </a:rPr>
+              <a:t>2</a:t>
+            </a:r>
+            <a:endParaRPr sz="1600">
+              <a:solidFill>
+                <a:srgbClr val="000000"/>
+              </a:solidFill>
+            </a:endParaRPr>
+          </a:p>
+        </p:txBody>
+      </p:sp>
+      <p:sp>
+        <p:nvSpPr>
+          <p:cNvPr id="520" name="Google Shape;520;p25"/>
+          <p:cNvSpPr/>
+          <p:nvPr>
+            <p:custDataLst>
+              <p:tags r:id="rId8"/>
+            </p:custDataLst>
+          </p:nvPr>
+        </p:nvSpPr>
+        <p:spPr>
+          <a:xfrm>
+            <a:off x="2999808" y="2351686"/>
+            <a:ext cx="593100" cy="611700"/>
+          </a:xfrm>
+          <a:prstGeom prst="ellipse">
+            <a:avLst/>
+          </a:prstGeom>
+          <a:gradFill>
+            <a:gsLst>
+              <a:gs pos="0">
+                <a:srgbClr val="E0EDBA">
+                  <a:alpha val="79215"/>
+                </a:srgbClr>
+              </a:gs>
+              <a:gs pos="100000">
+                <a:srgbClr val="DE87F1">
+                  <a:alpha val="48235"/>
+                </a:srgbClr>
+              </a:gs>
+            </a:gsLst>
+            <a:lin ang="13500032" scaled="0"/>
+          </a:gradFill>
+          <a:ln w="9525" cap="flat" cmpd="sng">
+            <a:solidFill>
+              <a:srgbClr val="595959"/>
+            </a:solidFill>
+            <a:prstDash val="solid"/>
+            <a:round/>
+            <a:headEnd type="none" w="sm" len="sm"/>
+            <a:tailEnd type="none" w="sm" len="sm"/>
+          </a:ln>
+        </p:spPr>
+        <p:txBody>
+          <a:bodyPr spcFirstLastPara="1" wrap="square" lIns="91425" tIns="91425" rIns="91425" bIns="91425" anchor="ctr" anchorCtr="0">
+            <a:noAutofit/>
+          </a:bodyPr>
+          <a:p>
+            <a:pPr marL="0" lvl="0" indent="0" algn="l" rtl="0">
+              <a:spcBef>
+                <a:spcPts val="0"/>
+              </a:spcBef>
+              <a:spcAft>
+                <a:spcPts val="0"/>
+              </a:spcAft>
+              <a:buClr>
+                <a:srgbClr val="000000"/>
+              </a:buClr>
+              <a:buSzPts val="1100"/>
+              <a:buFont typeface="Arial" panose="020B0704020202020204"/>
+              <a:buNone/>
+            </a:pPr>
+            <a:r>
+              <a:rPr lang="en-GB" sz="1100">
+                <a:solidFill>
+                  <a:srgbClr val="000000"/>
+                </a:solidFill>
+              </a:rPr>
+              <a:t>a</a:t>
+            </a:r>
+            <a:r>
+              <a:rPr lang="en-GB" sz="1100" baseline="30000">
+                <a:solidFill>
+                  <a:srgbClr val="000000"/>
+                </a:solidFill>
+              </a:rPr>
+              <a:t>[1]</a:t>
+            </a:r>
+            <a:r>
+              <a:rPr lang="en-GB" sz="1100" baseline="-25000">
+                <a:solidFill>
+                  <a:srgbClr val="000000"/>
+                </a:solidFill>
+              </a:rPr>
+              <a:t>3</a:t>
+            </a:r>
+            <a:endParaRPr sz="1600">
+              <a:solidFill>
+                <a:srgbClr val="000000"/>
+              </a:solidFill>
+            </a:endParaRPr>
+          </a:p>
+        </p:txBody>
+      </p:sp>
+      <p:sp>
+        <p:nvSpPr>
+          <p:cNvPr id="521" name="Google Shape;521;p25"/>
+          <p:cNvSpPr/>
+          <p:nvPr>
+            <p:custDataLst>
+              <p:tags r:id="rId9"/>
+            </p:custDataLst>
+          </p:nvPr>
+        </p:nvSpPr>
+        <p:spPr>
+          <a:xfrm>
+            <a:off x="2999808" y="3587234"/>
+            <a:ext cx="587100" cy="611700"/>
+          </a:xfrm>
+          <a:prstGeom prst="ellipse">
+            <a:avLst/>
+          </a:prstGeom>
+          <a:gradFill>
+            <a:gsLst>
+              <a:gs pos="0">
+                <a:srgbClr val="E0EDBA">
+                  <a:alpha val="79215"/>
+                </a:srgbClr>
+              </a:gs>
+              <a:gs pos="100000">
+                <a:srgbClr val="DE87F1">
+                  <a:alpha val="48235"/>
+                </a:srgbClr>
+              </a:gs>
+            </a:gsLst>
+            <a:lin ang="13500032" scaled="0"/>
+          </a:gradFill>
+          <a:ln w="9525" cap="flat" cmpd="sng">
+            <a:solidFill>
+              <a:srgbClr val="595959"/>
+            </a:solidFill>
+            <a:prstDash val="solid"/>
+            <a:round/>
+            <a:headEnd type="none" w="sm" len="sm"/>
+            <a:tailEnd type="none" w="sm" len="sm"/>
+          </a:ln>
+        </p:spPr>
+        <p:txBody>
+          <a:bodyPr spcFirstLastPara="1" wrap="square" lIns="91425" tIns="91425" rIns="91425" bIns="91425" anchor="ctr" anchorCtr="0">
+            <a:noAutofit/>
+          </a:bodyPr>
+          <a:p>
+            <a:pPr marL="0" lvl="0" indent="0" algn="l" rtl="0">
+              <a:spcBef>
+                <a:spcPts val="0"/>
+              </a:spcBef>
+              <a:spcAft>
+                <a:spcPts val="0"/>
+              </a:spcAft>
+              <a:buClr>
+                <a:srgbClr val="000000"/>
+              </a:buClr>
+              <a:buSzPts val="1100"/>
+              <a:buFont typeface="Arial" panose="020B0704020202020204"/>
+              <a:buNone/>
+            </a:pPr>
+            <a:r>
+              <a:rPr lang="en-GB" sz="1100">
+                <a:solidFill>
+                  <a:srgbClr val="000000"/>
+                </a:solidFill>
+              </a:rPr>
+              <a:t>a</a:t>
+            </a:r>
+            <a:r>
+              <a:rPr lang="en-GB" sz="1100" baseline="30000">
+                <a:solidFill>
+                  <a:srgbClr val="000000"/>
+                </a:solidFill>
+              </a:rPr>
+              <a:t>[1]</a:t>
+            </a:r>
+            <a:r>
+              <a:rPr lang="en-GB" sz="1100" baseline="-25000">
+                <a:solidFill>
+                  <a:srgbClr val="000000"/>
+                </a:solidFill>
+              </a:rPr>
+              <a:t>n</a:t>
+            </a:r>
+            <a:endParaRPr sz="1100">
+              <a:solidFill>
+                <a:srgbClr val="000000"/>
+              </a:solidFill>
+            </a:endParaRPr>
+          </a:p>
+        </p:txBody>
+      </p:sp>
+      <p:sp>
+        <p:nvSpPr>
+          <p:cNvPr id="518" name="Google Shape;518;p25"/>
+          <p:cNvSpPr/>
+          <p:nvPr>
+            <p:custDataLst>
+              <p:tags r:id="rId10"/>
+            </p:custDataLst>
+          </p:nvPr>
+        </p:nvSpPr>
+        <p:spPr>
+          <a:xfrm>
+            <a:off x="4343108" y="803241"/>
+            <a:ext cx="593100" cy="611700"/>
+          </a:xfrm>
+          <a:prstGeom prst="ellipse">
+            <a:avLst/>
+          </a:prstGeom>
+          <a:gradFill>
+            <a:gsLst>
+              <a:gs pos="0">
+                <a:srgbClr val="E0EDBA">
+                  <a:alpha val="79215"/>
+                </a:srgbClr>
+              </a:gs>
+              <a:gs pos="100000">
+                <a:srgbClr val="DE87F1">
+                  <a:alpha val="48235"/>
+                </a:srgbClr>
+              </a:gs>
+            </a:gsLst>
+            <a:lin ang="13500032" scaled="0"/>
+          </a:gradFill>
+          <a:ln w="9525" cap="flat" cmpd="sng">
+            <a:solidFill>
+              <a:srgbClr val="595959"/>
+            </a:solidFill>
+            <a:prstDash val="solid"/>
+            <a:round/>
+            <a:headEnd type="none" w="sm" len="sm"/>
+            <a:tailEnd type="none" w="sm" len="sm"/>
+          </a:ln>
+        </p:spPr>
+        <p:txBody>
+          <a:bodyPr spcFirstLastPara="1" wrap="square" lIns="91425" tIns="91425" rIns="91425" bIns="91425" anchor="ctr" anchorCtr="0">
+            <a:noAutofit/>
+          </a:bodyPr>
+          <a:p>
+            <a:pPr marL="0" lvl="0" indent="0" algn="l" rtl="0">
+              <a:spcBef>
+                <a:spcPts val="0"/>
+              </a:spcBef>
+              <a:spcAft>
+                <a:spcPts val="0"/>
+              </a:spcAft>
+              <a:buClr>
+                <a:srgbClr val="000000"/>
+              </a:buClr>
+              <a:buSzPts val="1100"/>
+              <a:buFont typeface="Arial" panose="020B0704020202020204"/>
+              <a:buNone/>
+            </a:pPr>
+            <a:r>
+              <a:rPr lang="en-GB" sz="1100">
+                <a:solidFill>
+                  <a:srgbClr val="000000"/>
+                </a:solidFill>
+              </a:rPr>
+              <a:t>a</a:t>
+            </a:r>
+            <a:r>
+              <a:rPr lang="en-GB" sz="1100" baseline="30000">
+                <a:solidFill>
+                  <a:srgbClr val="000000"/>
+                </a:solidFill>
+              </a:rPr>
+              <a:t>[2]</a:t>
+            </a:r>
+            <a:r>
+              <a:rPr lang="en-GB" sz="1100" baseline="-25000">
+                <a:solidFill>
+                  <a:srgbClr val="000000"/>
+                </a:solidFill>
+              </a:rPr>
+              <a:t>1</a:t>
+            </a:r>
+            <a:endParaRPr sz="1200" baseline="-25000"/>
+          </a:p>
+        </p:txBody>
+      </p:sp>
+      <p:sp>
+        <p:nvSpPr>
+          <p:cNvPr id="522" name="Google Shape;522;p25"/>
+          <p:cNvSpPr/>
+          <p:nvPr>
+            <p:custDataLst>
+              <p:tags r:id="rId11"/>
+            </p:custDataLst>
+          </p:nvPr>
+        </p:nvSpPr>
+        <p:spPr>
+          <a:xfrm>
+            <a:off x="4343108" y="1614563"/>
+            <a:ext cx="593100" cy="611700"/>
+          </a:xfrm>
+          <a:prstGeom prst="ellipse">
+            <a:avLst/>
+          </a:prstGeom>
+          <a:gradFill>
+            <a:gsLst>
+              <a:gs pos="0">
+                <a:srgbClr val="E0EDBA">
+                  <a:alpha val="79215"/>
+                </a:srgbClr>
+              </a:gs>
+              <a:gs pos="100000">
+                <a:srgbClr val="DE87F1">
+                  <a:alpha val="48235"/>
+                </a:srgbClr>
+              </a:gs>
+            </a:gsLst>
+            <a:lin ang="13500032" scaled="0"/>
+          </a:gradFill>
+          <a:ln w="9525" cap="flat" cmpd="sng">
+            <a:solidFill>
+              <a:srgbClr val="595959"/>
+            </a:solidFill>
+            <a:prstDash val="solid"/>
+            <a:round/>
+            <a:headEnd type="none" w="sm" len="sm"/>
+            <a:tailEnd type="none" w="sm" len="sm"/>
+          </a:ln>
+        </p:spPr>
+        <p:txBody>
+          <a:bodyPr spcFirstLastPara="1" wrap="square" lIns="91425" tIns="91425" rIns="91425" bIns="91425" anchor="ctr" anchorCtr="0">
+            <a:noAutofit/>
+          </a:bodyPr>
+          <a:p>
+            <a:pPr marL="0" lvl="0" indent="0" algn="l" rtl="0">
+              <a:spcBef>
+                <a:spcPts val="0"/>
+              </a:spcBef>
+              <a:spcAft>
+                <a:spcPts val="0"/>
+              </a:spcAft>
+              <a:buClr>
+                <a:srgbClr val="000000"/>
+              </a:buClr>
+              <a:buSzPts val="1100"/>
+              <a:buFont typeface="Arial" panose="020B0704020202020204"/>
+              <a:buNone/>
+            </a:pPr>
+            <a:r>
+              <a:rPr lang="en-GB" sz="1100">
+                <a:solidFill>
+                  <a:srgbClr val="000000"/>
+                </a:solidFill>
+              </a:rPr>
+              <a:t>a</a:t>
+            </a:r>
+            <a:r>
+              <a:rPr lang="en-GB" sz="1100" baseline="30000">
+                <a:solidFill>
+                  <a:srgbClr val="000000"/>
+                </a:solidFill>
+              </a:rPr>
+              <a:t>[2]</a:t>
+            </a:r>
+            <a:r>
+              <a:rPr lang="en-GB" sz="1100" baseline="-25000">
+                <a:solidFill>
+                  <a:srgbClr val="000000"/>
+                </a:solidFill>
+              </a:rPr>
+              <a:t>2</a:t>
+            </a:r>
+            <a:endParaRPr sz="1600">
+              <a:solidFill>
+                <a:srgbClr val="000000"/>
+              </a:solidFill>
+            </a:endParaRPr>
+          </a:p>
+        </p:txBody>
+      </p:sp>
+      <p:sp>
+        <p:nvSpPr>
+          <p:cNvPr id="523" name="Google Shape;523;p25"/>
+          <p:cNvSpPr/>
+          <p:nvPr>
+            <p:custDataLst>
+              <p:tags r:id="rId12"/>
+            </p:custDataLst>
+          </p:nvPr>
+        </p:nvSpPr>
+        <p:spPr>
+          <a:xfrm>
+            <a:off x="4343108" y="2378761"/>
+            <a:ext cx="593100" cy="611700"/>
+          </a:xfrm>
+          <a:prstGeom prst="ellipse">
+            <a:avLst/>
+          </a:prstGeom>
+          <a:gradFill>
+            <a:gsLst>
+              <a:gs pos="0">
+                <a:srgbClr val="E0EDBA">
+                  <a:alpha val="79215"/>
+                </a:srgbClr>
+              </a:gs>
+              <a:gs pos="100000">
+                <a:srgbClr val="DE87F1">
+                  <a:alpha val="48235"/>
+                </a:srgbClr>
+              </a:gs>
+            </a:gsLst>
+            <a:lin ang="13500032" scaled="0"/>
+          </a:gradFill>
+          <a:ln w="9525" cap="flat" cmpd="sng">
+            <a:solidFill>
+              <a:srgbClr val="595959"/>
+            </a:solidFill>
+            <a:prstDash val="solid"/>
+            <a:round/>
+            <a:headEnd type="none" w="sm" len="sm"/>
+            <a:tailEnd type="none" w="sm" len="sm"/>
+          </a:ln>
+        </p:spPr>
+        <p:txBody>
+          <a:bodyPr spcFirstLastPara="1" wrap="square" lIns="91425" tIns="91425" rIns="91425" bIns="91425" anchor="ctr" anchorCtr="0">
+            <a:noAutofit/>
+          </a:bodyPr>
+          <a:p>
+            <a:pPr marL="0" lvl="0" indent="0" algn="l" rtl="0">
+              <a:spcBef>
+                <a:spcPts val="0"/>
+              </a:spcBef>
+              <a:spcAft>
+                <a:spcPts val="0"/>
+              </a:spcAft>
+              <a:buClr>
+                <a:srgbClr val="000000"/>
+              </a:buClr>
+              <a:buSzPts val="1100"/>
+              <a:buFont typeface="Arial" panose="020B0704020202020204"/>
+              <a:buNone/>
+            </a:pPr>
+            <a:r>
+              <a:rPr lang="en-GB" sz="1100">
+                <a:solidFill>
+                  <a:srgbClr val="000000"/>
+                </a:solidFill>
+              </a:rPr>
+              <a:t>a</a:t>
+            </a:r>
+            <a:r>
+              <a:rPr lang="en-GB" sz="1100" baseline="30000">
+                <a:solidFill>
+                  <a:srgbClr val="000000"/>
+                </a:solidFill>
+              </a:rPr>
+              <a:t>[2]</a:t>
+            </a:r>
+            <a:r>
+              <a:rPr lang="en-GB" sz="1100" baseline="-25000">
+                <a:solidFill>
+                  <a:srgbClr val="000000"/>
+                </a:solidFill>
+              </a:rPr>
+              <a:t>3</a:t>
+            </a:r>
+            <a:endParaRPr sz="1600">
+              <a:solidFill>
+                <a:srgbClr val="000000"/>
+              </a:solidFill>
+            </a:endParaRPr>
+          </a:p>
+        </p:txBody>
+      </p:sp>
+      <p:sp>
+        <p:nvSpPr>
+          <p:cNvPr id="524" name="Google Shape;524;p25"/>
+          <p:cNvSpPr/>
+          <p:nvPr>
+            <p:custDataLst>
+              <p:tags r:id="rId13"/>
+            </p:custDataLst>
+          </p:nvPr>
+        </p:nvSpPr>
+        <p:spPr>
+          <a:xfrm>
+            <a:off x="4343108" y="3587234"/>
+            <a:ext cx="593100" cy="611700"/>
+          </a:xfrm>
+          <a:prstGeom prst="ellipse">
+            <a:avLst/>
+          </a:prstGeom>
+          <a:gradFill>
+            <a:gsLst>
+              <a:gs pos="0">
+                <a:srgbClr val="E0EDBA">
+                  <a:alpha val="79215"/>
+                </a:srgbClr>
+              </a:gs>
+              <a:gs pos="100000">
+                <a:srgbClr val="DE87F1">
+                  <a:alpha val="48235"/>
+                </a:srgbClr>
+              </a:gs>
+            </a:gsLst>
+            <a:lin ang="13500032" scaled="0"/>
+          </a:gradFill>
+          <a:ln w="9525" cap="flat" cmpd="sng">
+            <a:solidFill>
+              <a:srgbClr val="595959"/>
+            </a:solidFill>
+            <a:prstDash val="solid"/>
+            <a:round/>
+            <a:headEnd type="none" w="sm" len="sm"/>
+            <a:tailEnd type="none" w="sm" len="sm"/>
+          </a:ln>
+        </p:spPr>
+        <p:txBody>
+          <a:bodyPr spcFirstLastPara="1" wrap="square" lIns="91425" tIns="91425" rIns="91425" bIns="91425" anchor="ctr" anchorCtr="0">
+            <a:noAutofit/>
+          </a:bodyPr>
+          <a:p>
+            <a:pPr marL="0" lvl="0" indent="0" algn="l" rtl="0">
+              <a:spcBef>
+                <a:spcPts val="0"/>
+              </a:spcBef>
+              <a:spcAft>
+                <a:spcPts val="0"/>
+              </a:spcAft>
+              <a:buClr>
+                <a:srgbClr val="000000"/>
+              </a:buClr>
+              <a:buSzPts val="1100"/>
+              <a:buFont typeface="Arial" panose="020B0704020202020204"/>
+              <a:buNone/>
+            </a:pPr>
+            <a:r>
+              <a:rPr lang="en-GB" sz="1100">
+                <a:solidFill>
+                  <a:srgbClr val="000000"/>
+                </a:solidFill>
+              </a:rPr>
+              <a:t>a</a:t>
+            </a:r>
+            <a:r>
+              <a:rPr lang="en-GB" sz="1100" baseline="30000">
+                <a:solidFill>
+                  <a:srgbClr val="000000"/>
+                </a:solidFill>
+              </a:rPr>
+              <a:t>[2]</a:t>
+            </a:r>
+            <a:r>
+              <a:rPr lang="en-GB" sz="1100" baseline="-25000">
+                <a:solidFill>
+                  <a:srgbClr val="000000"/>
+                </a:solidFill>
+              </a:rPr>
+              <a:t>n</a:t>
+            </a:r>
+            <a:endParaRPr sz="1600">
+              <a:solidFill>
+                <a:srgbClr val="000000"/>
+              </a:solidFill>
+            </a:endParaRPr>
+          </a:p>
+        </p:txBody>
+      </p:sp>
+      <p:sp>
+        <p:nvSpPr>
+          <p:cNvPr id="515" name="Google Shape;515;p25"/>
+          <p:cNvSpPr/>
+          <p:nvPr>
+            <p:custDataLst>
+              <p:tags r:id="rId14"/>
+            </p:custDataLst>
+          </p:nvPr>
+        </p:nvSpPr>
+        <p:spPr>
+          <a:xfrm>
+            <a:off x="5686908" y="803241"/>
+            <a:ext cx="593100" cy="611700"/>
+          </a:xfrm>
+          <a:prstGeom prst="ellipse">
+            <a:avLst/>
+          </a:prstGeom>
+          <a:gradFill>
+            <a:gsLst>
+              <a:gs pos="0">
+                <a:srgbClr val="E0EDBA">
+                  <a:alpha val="79215"/>
+                </a:srgbClr>
+              </a:gs>
+              <a:gs pos="100000">
+                <a:srgbClr val="DE87F1">
+                  <a:alpha val="39607"/>
+                </a:srgbClr>
+              </a:gs>
+            </a:gsLst>
+            <a:lin ang="13500032" scaled="0"/>
+          </a:gradFill>
+          <a:ln w="9525" cap="flat" cmpd="sng">
+            <a:solidFill>
+              <a:srgbClr val="595959"/>
+            </a:solidFill>
+            <a:prstDash val="solid"/>
+            <a:round/>
+            <a:headEnd type="none" w="sm" len="sm"/>
+            <a:tailEnd type="none" w="sm" len="sm"/>
+          </a:ln>
+        </p:spPr>
+        <p:txBody>
+          <a:bodyPr spcFirstLastPara="1" wrap="square" lIns="91425" tIns="91425" rIns="91425" bIns="91425" anchor="ctr" anchorCtr="0">
+            <a:noAutofit/>
+          </a:bodyPr>
+          <a:p>
+            <a:pPr marL="0" lvl="0" indent="0" algn="l" rtl="0">
+              <a:spcBef>
+                <a:spcPts val="0"/>
+              </a:spcBef>
+              <a:spcAft>
+                <a:spcPts val="0"/>
+              </a:spcAft>
+              <a:buClr>
+                <a:srgbClr val="000000"/>
+              </a:buClr>
+              <a:buSzPts val="1100"/>
+              <a:buFont typeface="Arial" panose="020B0704020202020204"/>
+              <a:buNone/>
+            </a:pPr>
+            <a:r>
+              <a:rPr lang="en-GB" sz="1100">
+                <a:solidFill>
+                  <a:srgbClr val="000000"/>
+                </a:solidFill>
+              </a:rPr>
+              <a:t>a</a:t>
+            </a:r>
+            <a:r>
+              <a:rPr lang="en-GB" sz="1100" baseline="30000">
+                <a:solidFill>
+                  <a:srgbClr val="000000"/>
+                </a:solidFill>
+              </a:rPr>
+              <a:t>[3]</a:t>
+            </a:r>
+            <a:r>
+              <a:rPr lang="en-GB" sz="1100" baseline="-25000">
+                <a:solidFill>
+                  <a:srgbClr val="000000"/>
+                </a:solidFill>
+              </a:rPr>
+              <a:t>1</a:t>
+            </a:r>
+            <a:endParaRPr sz="1200" baseline="-25000"/>
+          </a:p>
+        </p:txBody>
+      </p:sp>
+      <p:sp>
+        <p:nvSpPr>
+          <p:cNvPr id="513" name="Google Shape;513;p25"/>
+          <p:cNvSpPr/>
+          <p:nvPr>
+            <p:custDataLst>
+              <p:tags r:id="rId15"/>
+            </p:custDataLst>
+          </p:nvPr>
+        </p:nvSpPr>
+        <p:spPr>
+          <a:xfrm>
+            <a:off x="5686908" y="1577513"/>
+            <a:ext cx="593100" cy="611700"/>
+          </a:xfrm>
+          <a:prstGeom prst="ellipse">
+            <a:avLst/>
+          </a:prstGeom>
+          <a:gradFill>
+            <a:gsLst>
+              <a:gs pos="0">
+                <a:srgbClr val="E0EDBA">
+                  <a:alpha val="79215"/>
+                </a:srgbClr>
+              </a:gs>
+              <a:gs pos="100000">
+                <a:srgbClr val="DE87F1">
+                  <a:alpha val="39607"/>
+                </a:srgbClr>
+              </a:gs>
+            </a:gsLst>
+            <a:lin ang="13500032" scaled="0"/>
+          </a:gradFill>
+          <a:ln w="9525" cap="flat" cmpd="sng">
+            <a:solidFill>
+              <a:srgbClr val="595959"/>
+            </a:solidFill>
+            <a:prstDash val="solid"/>
+            <a:round/>
+            <a:headEnd type="none" w="sm" len="sm"/>
+            <a:tailEnd type="none" w="sm" len="sm"/>
+          </a:ln>
+        </p:spPr>
+        <p:txBody>
+          <a:bodyPr spcFirstLastPara="1" wrap="square" lIns="91425" tIns="91425" rIns="91425" bIns="91425" anchor="ctr" anchorCtr="0">
+            <a:noAutofit/>
+          </a:bodyPr>
+          <a:p>
+            <a:pPr marL="0" lvl="0" indent="0" algn="l" rtl="0">
+              <a:spcBef>
+                <a:spcPts val="0"/>
+              </a:spcBef>
+              <a:spcAft>
+                <a:spcPts val="0"/>
+              </a:spcAft>
+              <a:buClr>
+                <a:srgbClr val="000000"/>
+              </a:buClr>
+              <a:buSzPts val="1100"/>
+              <a:buFont typeface="Arial" panose="020B0704020202020204"/>
+              <a:buNone/>
+            </a:pPr>
+            <a:r>
+              <a:rPr lang="en-GB" sz="1100">
+                <a:solidFill>
+                  <a:srgbClr val="000000"/>
+                </a:solidFill>
+              </a:rPr>
+              <a:t>a</a:t>
+            </a:r>
+            <a:r>
+              <a:rPr lang="en-GB" sz="1100" baseline="30000">
+                <a:solidFill>
+                  <a:srgbClr val="000000"/>
+                </a:solidFill>
+              </a:rPr>
+              <a:t>[3]</a:t>
+            </a:r>
+            <a:r>
+              <a:rPr lang="en-GB" sz="1100" baseline="-25000">
+                <a:solidFill>
+                  <a:srgbClr val="000000"/>
+                </a:solidFill>
+              </a:rPr>
+              <a:t>2</a:t>
+            </a:r>
+            <a:endParaRPr sz="1600">
+              <a:solidFill>
+                <a:srgbClr val="000000"/>
+              </a:solidFill>
+            </a:endParaRPr>
+          </a:p>
+        </p:txBody>
+      </p:sp>
+      <p:sp>
+        <p:nvSpPr>
+          <p:cNvPr id="525" name="Google Shape;525;p25"/>
+          <p:cNvSpPr/>
+          <p:nvPr>
+            <p:custDataLst>
+              <p:tags r:id="rId16"/>
+            </p:custDataLst>
+          </p:nvPr>
+        </p:nvSpPr>
+        <p:spPr>
+          <a:xfrm>
+            <a:off x="5686896" y="2351811"/>
+            <a:ext cx="593100" cy="611700"/>
+          </a:xfrm>
+          <a:prstGeom prst="ellipse">
+            <a:avLst/>
+          </a:prstGeom>
+          <a:gradFill>
+            <a:gsLst>
+              <a:gs pos="0">
+                <a:srgbClr val="E0EDBA">
+                  <a:alpha val="79215"/>
+                </a:srgbClr>
+              </a:gs>
+              <a:gs pos="100000">
+                <a:srgbClr val="DE87F1">
+                  <a:alpha val="39607"/>
+                </a:srgbClr>
+              </a:gs>
+            </a:gsLst>
+            <a:lin ang="13500032" scaled="0"/>
+          </a:gradFill>
+          <a:ln w="9525" cap="flat" cmpd="sng">
+            <a:solidFill>
+              <a:srgbClr val="595959"/>
+            </a:solidFill>
+            <a:prstDash val="solid"/>
+            <a:round/>
+            <a:headEnd type="none" w="sm" len="sm"/>
+            <a:tailEnd type="none" w="sm" len="sm"/>
+          </a:ln>
+        </p:spPr>
+        <p:txBody>
+          <a:bodyPr spcFirstLastPara="1" wrap="square" lIns="91425" tIns="91425" rIns="91425" bIns="91425" anchor="ctr" anchorCtr="0">
+            <a:noAutofit/>
+          </a:bodyPr>
+          <a:p>
+            <a:pPr marL="0" lvl="0" indent="0" algn="l" rtl="0">
+              <a:spcBef>
+                <a:spcPts val="0"/>
+              </a:spcBef>
+              <a:spcAft>
+                <a:spcPts val="0"/>
+              </a:spcAft>
+              <a:buClr>
+                <a:srgbClr val="000000"/>
+              </a:buClr>
+              <a:buSzPts val="1100"/>
+              <a:buFont typeface="Arial" panose="020B0704020202020204"/>
+              <a:buNone/>
+            </a:pPr>
+            <a:r>
+              <a:rPr lang="en-GB" sz="1100">
+                <a:solidFill>
+                  <a:srgbClr val="000000"/>
+                </a:solidFill>
+              </a:rPr>
+              <a:t>a</a:t>
+            </a:r>
+            <a:r>
+              <a:rPr lang="en-GB" sz="1100" baseline="30000">
+                <a:solidFill>
+                  <a:srgbClr val="000000"/>
+                </a:solidFill>
+              </a:rPr>
+              <a:t>[3]</a:t>
+            </a:r>
+            <a:r>
+              <a:rPr lang="en-GB" sz="1100" baseline="-25000">
+                <a:solidFill>
+                  <a:srgbClr val="000000"/>
+                </a:solidFill>
+              </a:rPr>
+              <a:t>3</a:t>
+            </a:r>
+            <a:endParaRPr sz="1600">
+              <a:solidFill>
+                <a:srgbClr val="000000"/>
+              </a:solidFill>
+            </a:endParaRPr>
+          </a:p>
+        </p:txBody>
+      </p:sp>
+      <p:sp>
+        <p:nvSpPr>
+          <p:cNvPr id="511" name="Google Shape;511;p25"/>
+          <p:cNvSpPr/>
+          <p:nvPr>
+            <p:custDataLst>
+              <p:tags r:id="rId17"/>
+            </p:custDataLst>
+          </p:nvPr>
+        </p:nvSpPr>
+        <p:spPr>
+          <a:xfrm>
+            <a:off x="5686908" y="3569534"/>
+            <a:ext cx="593100" cy="611700"/>
+          </a:xfrm>
+          <a:prstGeom prst="ellipse">
+            <a:avLst/>
+          </a:prstGeom>
+          <a:gradFill>
+            <a:gsLst>
+              <a:gs pos="0">
+                <a:srgbClr val="E0EDBA">
+                  <a:alpha val="79215"/>
+                </a:srgbClr>
+              </a:gs>
+              <a:gs pos="100000">
+                <a:srgbClr val="DE87F1">
+                  <a:alpha val="39607"/>
+                </a:srgbClr>
+              </a:gs>
+            </a:gsLst>
+            <a:lin ang="13500032" scaled="0"/>
+          </a:gradFill>
+          <a:ln w="9525" cap="flat" cmpd="sng">
+            <a:solidFill>
+              <a:srgbClr val="595959"/>
+            </a:solidFill>
+            <a:prstDash val="solid"/>
+            <a:round/>
+            <a:headEnd type="none" w="sm" len="sm"/>
+            <a:tailEnd type="none" w="sm" len="sm"/>
+          </a:ln>
+        </p:spPr>
+        <p:txBody>
+          <a:bodyPr spcFirstLastPara="1" wrap="square" lIns="91425" tIns="91425" rIns="91425" bIns="91425" anchor="ctr" anchorCtr="0">
+            <a:noAutofit/>
+          </a:bodyPr>
+          <a:p>
+            <a:pPr marL="0" lvl="0" indent="0" algn="l" rtl="0">
+              <a:spcBef>
+                <a:spcPts val="0"/>
+              </a:spcBef>
+              <a:spcAft>
+                <a:spcPts val="0"/>
+              </a:spcAft>
+              <a:buClr>
+                <a:srgbClr val="000000"/>
+              </a:buClr>
+              <a:buSzPts val="1100"/>
+              <a:buFont typeface="Arial" panose="020B0704020202020204"/>
+              <a:buNone/>
+            </a:pPr>
+            <a:r>
+              <a:rPr lang="en-GB" sz="1100">
+                <a:solidFill>
+                  <a:srgbClr val="000000"/>
+                </a:solidFill>
+              </a:rPr>
+              <a:t>a</a:t>
+            </a:r>
+            <a:r>
+              <a:rPr lang="en-GB" sz="1100" baseline="30000">
+                <a:solidFill>
+                  <a:srgbClr val="000000"/>
+                </a:solidFill>
+              </a:rPr>
+              <a:t>[3]</a:t>
+            </a:r>
+            <a:r>
+              <a:rPr lang="en-GB" sz="1100" baseline="-25000">
+                <a:solidFill>
+                  <a:srgbClr val="000000"/>
+                </a:solidFill>
+              </a:rPr>
+              <a:t>n</a:t>
+            </a:r>
+            <a:endParaRPr sz="1600">
+              <a:solidFill>
+                <a:srgbClr val="000000"/>
+              </a:solidFill>
+            </a:endParaRPr>
+          </a:p>
+        </p:txBody>
+      </p:sp>
+      <p:cxnSp>
+        <p:nvCxnSpPr>
+          <p:cNvPr id="526" name="Google Shape;526;p25"/>
+          <p:cNvCxnSpPr/>
+          <p:nvPr>
+            <p:custDataLst>
+              <p:tags r:id="rId18"/>
+            </p:custDataLst>
+          </p:nvPr>
+        </p:nvCxnSpPr>
+        <p:spPr>
+          <a:xfrm flipH="1">
+            <a:off x="3293350" y="3088775"/>
+            <a:ext cx="6000" cy="450000"/>
+          </a:xfrm>
+          <a:prstGeom prst="straightConnector1">
+            <a:avLst/>
+          </a:prstGeom>
+          <a:noFill/>
+          <a:ln w="28575" cap="flat" cmpd="sng">
+            <a:solidFill>
+              <a:srgbClr val="595959"/>
+            </a:solidFill>
+            <a:prstDash val="dot"/>
+            <a:round/>
+            <a:headEnd type="none" w="med" len="med"/>
+            <a:tailEnd type="none" w="med" len="med"/>
+          </a:ln>
+        </p:spPr>
+      </p:cxnSp>
+      <p:cxnSp>
+        <p:nvCxnSpPr>
+          <p:cNvPr id="559" name="Google Shape;559;p25"/>
+          <p:cNvCxnSpPr>
+            <a:stCxn id="517" idx="6"/>
+            <a:endCxn id="522" idx="2"/>
+          </p:cNvCxnSpPr>
+          <p:nvPr>
+            <p:custDataLst>
+              <p:tags r:id="rId19"/>
+            </p:custDataLst>
+          </p:nvPr>
+        </p:nvCxnSpPr>
+        <p:spPr>
+          <a:xfrm>
+            <a:off x="3592908" y="1109091"/>
+            <a:ext cx="750300" cy="811200"/>
+          </a:xfrm>
+          <a:prstGeom prst="straightConnector1">
+            <a:avLst/>
+          </a:prstGeom>
+          <a:noFill/>
+          <a:ln w="9525" cap="flat" cmpd="sng">
+            <a:solidFill>
+              <a:srgbClr val="595959"/>
+            </a:solidFill>
+            <a:prstDash val="solid"/>
+            <a:round/>
+            <a:headEnd type="none" w="med" len="med"/>
+            <a:tailEnd type="triangle" w="med" len="med"/>
+          </a:ln>
+        </p:spPr>
+      </p:cxnSp>
+      <p:cxnSp>
+        <p:nvCxnSpPr>
+          <p:cNvPr id="560" name="Google Shape;560;p25"/>
+          <p:cNvCxnSpPr>
+            <a:stCxn id="517" idx="6"/>
+            <a:endCxn id="523" idx="2"/>
+          </p:cNvCxnSpPr>
+          <p:nvPr>
+            <p:custDataLst>
+              <p:tags r:id="rId20"/>
+            </p:custDataLst>
+          </p:nvPr>
+        </p:nvCxnSpPr>
+        <p:spPr>
+          <a:xfrm>
+            <a:off x="3592908" y="1109091"/>
+            <a:ext cx="750300" cy="1575600"/>
+          </a:xfrm>
+          <a:prstGeom prst="straightConnector1">
+            <a:avLst/>
+          </a:prstGeom>
+          <a:noFill/>
+          <a:ln w="9525" cap="flat" cmpd="sng">
+            <a:solidFill>
+              <a:srgbClr val="595959"/>
+            </a:solidFill>
+            <a:prstDash val="solid"/>
+            <a:round/>
+            <a:headEnd type="none" w="med" len="med"/>
+            <a:tailEnd type="triangle" w="med" len="med"/>
+          </a:ln>
+        </p:spPr>
+      </p:cxnSp>
+      <p:cxnSp>
+        <p:nvCxnSpPr>
+          <p:cNvPr id="561" name="Google Shape;561;p25"/>
+          <p:cNvCxnSpPr>
+            <a:stCxn id="517" idx="6"/>
+            <a:endCxn id="524" idx="2"/>
+          </p:cNvCxnSpPr>
+          <p:nvPr>
+            <p:custDataLst>
+              <p:tags r:id="rId21"/>
+            </p:custDataLst>
+          </p:nvPr>
+        </p:nvCxnSpPr>
+        <p:spPr>
+          <a:xfrm>
+            <a:off x="3592908" y="1109091"/>
+            <a:ext cx="750300" cy="2784000"/>
+          </a:xfrm>
+          <a:prstGeom prst="straightConnector1">
+            <a:avLst/>
+          </a:prstGeom>
+          <a:noFill/>
+          <a:ln w="9525" cap="flat" cmpd="sng">
+            <a:solidFill>
+              <a:srgbClr val="595959"/>
+            </a:solidFill>
+            <a:prstDash val="solid"/>
+            <a:round/>
+            <a:headEnd type="none" w="med" len="med"/>
+            <a:tailEnd type="triangle" w="med" len="med"/>
+          </a:ln>
+        </p:spPr>
+      </p:cxnSp>
+      <p:cxnSp>
+        <p:nvCxnSpPr>
+          <p:cNvPr id="562" name="Google Shape;562;p25"/>
+          <p:cNvCxnSpPr>
+            <a:stCxn id="519" idx="6"/>
+            <a:endCxn id="518" idx="2"/>
+          </p:cNvCxnSpPr>
+          <p:nvPr>
+            <p:custDataLst>
+              <p:tags r:id="rId22"/>
+            </p:custDataLst>
+          </p:nvPr>
+        </p:nvCxnSpPr>
+        <p:spPr>
+          <a:xfrm rot="10800000" flipH="1">
+            <a:off x="3719908" y="1236213"/>
+            <a:ext cx="750300" cy="811200"/>
+          </a:xfrm>
+          <a:prstGeom prst="straightConnector1">
+            <a:avLst/>
+          </a:prstGeom>
+          <a:noFill/>
+          <a:ln w="9525" cap="flat" cmpd="sng">
+            <a:solidFill>
+              <a:srgbClr val="595959"/>
+            </a:solidFill>
+            <a:prstDash val="solid"/>
+            <a:round/>
+            <a:headEnd type="none" w="med" len="med"/>
+            <a:tailEnd type="triangle" w="med" len="med"/>
+          </a:ln>
+        </p:spPr>
+      </p:cxnSp>
+      <p:cxnSp>
+        <p:nvCxnSpPr>
+          <p:cNvPr id="563" name="Google Shape;563;p25"/>
+          <p:cNvCxnSpPr>
+            <a:stCxn id="519" idx="6"/>
+            <a:endCxn id="522" idx="2"/>
+          </p:cNvCxnSpPr>
+          <p:nvPr>
+            <p:custDataLst>
+              <p:tags r:id="rId23"/>
+            </p:custDataLst>
+          </p:nvPr>
+        </p:nvCxnSpPr>
+        <p:spPr>
+          <a:xfrm>
+            <a:off x="3592908" y="1920413"/>
+            <a:ext cx="750300" cy="0"/>
+          </a:xfrm>
+          <a:prstGeom prst="straightConnector1">
+            <a:avLst/>
+          </a:prstGeom>
+          <a:noFill/>
+          <a:ln w="9525" cap="flat" cmpd="sng">
+            <a:solidFill>
+              <a:srgbClr val="595959"/>
+            </a:solidFill>
+            <a:prstDash val="solid"/>
+            <a:round/>
+            <a:headEnd type="none" w="med" len="med"/>
+            <a:tailEnd type="triangle" w="med" len="med"/>
+          </a:ln>
+        </p:spPr>
+      </p:cxnSp>
+      <p:cxnSp>
+        <p:nvCxnSpPr>
+          <p:cNvPr id="564" name="Google Shape;564;p25"/>
+          <p:cNvCxnSpPr>
+            <a:stCxn id="519" idx="6"/>
+            <a:endCxn id="523" idx="2"/>
+          </p:cNvCxnSpPr>
+          <p:nvPr>
+            <p:custDataLst>
+              <p:tags r:id="rId24"/>
+            </p:custDataLst>
+          </p:nvPr>
+        </p:nvCxnSpPr>
+        <p:spPr>
+          <a:xfrm>
+            <a:off x="3592908" y="1920413"/>
+            <a:ext cx="750300" cy="764100"/>
+          </a:xfrm>
+          <a:prstGeom prst="straightConnector1">
+            <a:avLst/>
+          </a:prstGeom>
+          <a:noFill/>
+          <a:ln w="9525" cap="flat" cmpd="sng">
+            <a:solidFill>
+              <a:srgbClr val="595959"/>
+            </a:solidFill>
+            <a:prstDash val="solid"/>
+            <a:round/>
+            <a:headEnd type="none" w="med" len="med"/>
+            <a:tailEnd type="triangle" w="med" len="med"/>
+          </a:ln>
+        </p:spPr>
+      </p:cxnSp>
+      <p:cxnSp>
+        <p:nvCxnSpPr>
+          <p:cNvPr id="565" name="Google Shape;565;p25"/>
+          <p:cNvCxnSpPr>
+            <a:stCxn id="519" idx="6"/>
+            <a:endCxn id="524" idx="2"/>
+          </p:cNvCxnSpPr>
+          <p:nvPr>
+            <p:custDataLst>
+              <p:tags r:id="rId25"/>
+            </p:custDataLst>
+          </p:nvPr>
+        </p:nvCxnSpPr>
+        <p:spPr>
+          <a:xfrm>
+            <a:off x="3592908" y="1920413"/>
+            <a:ext cx="750300" cy="1972800"/>
+          </a:xfrm>
+          <a:prstGeom prst="straightConnector1">
+            <a:avLst/>
+          </a:prstGeom>
+          <a:noFill/>
+          <a:ln w="9525" cap="flat" cmpd="sng">
+            <a:solidFill>
+              <a:srgbClr val="595959"/>
+            </a:solidFill>
+            <a:prstDash val="solid"/>
+            <a:round/>
+            <a:headEnd type="none" w="med" len="med"/>
+            <a:tailEnd type="triangle" w="med" len="med"/>
+          </a:ln>
+        </p:spPr>
+      </p:cxnSp>
+      <p:cxnSp>
+        <p:nvCxnSpPr>
+          <p:cNvPr id="566" name="Google Shape;566;p25"/>
+          <p:cNvCxnSpPr>
+            <a:stCxn id="520" idx="6"/>
+            <a:endCxn id="518" idx="2"/>
+          </p:cNvCxnSpPr>
+          <p:nvPr>
+            <p:custDataLst>
+              <p:tags r:id="rId26"/>
+            </p:custDataLst>
+          </p:nvPr>
+        </p:nvCxnSpPr>
+        <p:spPr>
+          <a:xfrm rot="10800000" flipH="1">
+            <a:off x="3592908" y="1109236"/>
+            <a:ext cx="750300" cy="1548300"/>
+          </a:xfrm>
+          <a:prstGeom prst="straightConnector1">
+            <a:avLst/>
+          </a:prstGeom>
+          <a:noFill/>
+          <a:ln w="9525" cap="flat" cmpd="sng">
+            <a:solidFill>
+              <a:srgbClr val="595959"/>
+            </a:solidFill>
+            <a:prstDash val="solid"/>
+            <a:round/>
+            <a:headEnd type="none" w="med" len="med"/>
+            <a:tailEnd type="triangle" w="med" len="med"/>
+          </a:ln>
+        </p:spPr>
+      </p:cxnSp>
+      <p:cxnSp>
+        <p:nvCxnSpPr>
+          <p:cNvPr id="567" name="Google Shape;567;p25"/>
+          <p:cNvCxnSpPr>
+            <a:stCxn id="520" idx="6"/>
+            <a:endCxn id="522" idx="2"/>
+          </p:cNvCxnSpPr>
+          <p:nvPr>
+            <p:custDataLst>
+              <p:tags r:id="rId27"/>
+            </p:custDataLst>
+          </p:nvPr>
+        </p:nvCxnSpPr>
+        <p:spPr>
+          <a:xfrm rot="10800000" flipH="1">
+            <a:off x="3592908" y="1920436"/>
+            <a:ext cx="750300" cy="737100"/>
+          </a:xfrm>
+          <a:prstGeom prst="straightConnector1">
+            <a:avLst/>
+          </a:prstGeom>
+          <a:noFill/>
+          <a:ln w="9525" cap="flat" cmpd="sng">
+            <a:solidFill>
+              <a:srgbClr val="595959"/>
+            </a:solidFill>
+            <a:prstDash val="solid"/>
+            <a:round/>
+            <a:headEnd type="none" w="med" len="med"/>
+            <a:tailEnd type="triangle" w="med" len="med"/>
+          </a:ln>
+        </p:spPr>
+      </p:cxnSp>
+      <p:cxnSp>
+        <p:nvCxnSpPr>
+          <p:cNvPr id="568" name="Google Shape;568;p25"/>
+          <p:cNvCxnSpPr>
+            <a:stCxn id="520" idx="6"/>
+            <a:endCxn id="523" idx="2"/>
+          </p:cNvCxnSpPr>
+          <p:nvPr>
+            <p:custDataLst>
+              <p:tags r:id="rId28"/>
+            </p:custDataLst>
+          </p:nvPr>
+        </p:nvCxnSpPr>
+        <p:spPr>
+          <a:xfrm>
+            <a:off x="3592908" y="2657536"/>
+            <a:ext cx="750300" cy="27000"/>
+          </a:xfrm>
+          <a:prstGeom prst="straightConnector1">
+            <a:avLst/>
+          </a:prstGeom>
+          <a:noFill/>
+          <a:ln w="9525" cap="flat" cmpd="sng">
+            <a:solidFill>
+              <a:srgbClr val="595959"/>
+            </a:solidFill>
+            <a:prstDash val="solid"/>
+            <a:round/>
+            <a:headEnd type="none" w="med" len="med"/>
+            <a:tailEnd type="triangle" w="med" len="med"/>
+          </a:ln>
+        </p:spPr>
+      </p:cxnSp>
+      <p:cxnSp>
+        <p:nvCxnSpPr>
+          <p:cNvPr id="569" name="Google Shape;569;p25"/>
+          <p:cNvCxnSpPr>
+            <a:stCxn id="520" idx="6"/>
+            <a:endCxn id="524" idx="2"/>
+          </p:cNvCxnSpPr>
+          <p:nvPr>
+            <p:custDataLst>
+              <p:tags r:id="rId29"/>
+            </p:custDataLst>
+          </p:nvPr>
+        </p:nvCxnSpPr>
+        <p:spPr>
+          <a:xfrm>
+            <a:off x="3592908" y="2657536"/>
+            <a:ext cx="750300" cy="1235400"/>
+          </a:xfrm>
+          <a:prstGeom prst="straightConnector1">
+            <a:avLst/>
+          </a:prstGeom>
+          <a:noFill/>
+          <a:ln w="9525" cap="flat" cmpd="sng">
+            <a:solidFill>
+              <a:srgbClr val="595959"/>
+            </a:solidFill>
+            <a:prstDash val="solid"/>
+            <a:round/>
+            <a:headEnd type="none" w="med" len="med"/>
+            <a:tailEnd type="triangle" w="med" len="med"/>
+          </a:ln>
+        </p:spPr>
+      </p:cxnSp>
+      <p:cxnSp>
+        <p:nvCxnSpPr>
+          <p:cNvPr id="570" name="Google Shape;570;p25"/>
+          <p:cNvCxnSpPr/>
+          <p:nvPr>
+            <p:custDataLst>
+              <p:tags r:id="rId30"/>
+            </p:custDataLst>
+          </p:nvPr>
+        </p:nvCxnSpPr>
+        <p:spPr>
+          <a:xfrm rot="10800000" flipH="1">
+            <a:off x="3592808" y="1109091"/>
+            <a:ext cx="750300" cy="2819400"/>
+          </a:xfrm>
+          <a:prstGeom prst="straightConnector1">
+            <a:avLst/>
+          </a:prstGeom>
+          <a:noFill/>
+          <a:ln w="9525" cap="flat" cmpd="sng">
+            <a:solidFill>
+              <a:srgbClr val="595959"/>
+            </a:solidFill>
+            <a:prstDash val="solid"/>
+            <a:round/>
+            <a:headEnd type="none" w="med" len="med"/>
+            <a:tailEnd type="triangle" w="med" len="med"/>
+          </a:ln>
+        </p:spPr>
+      </p:cxnSp>
+      <p:cxnSp>
+        <p:nvCxnSpPr>
+          <p:cNvPr id="571" name="Google Shape;571;p25"/>
+          <p:cNvCxnSpPr>
+            <a:stCxn id="521" idx="6"/>
+            <a:endCxn id="522" idx="2"/>
+          </p:cNvCxnSpPr>
+          <p:nvPr>
+            <p:custDataLst>
+              <p:tags r:id="rId31"/>
+            </p:custDataLst>
+          </p:nvPr>
+        </p:nvCxnSpPr>
+        <p:spPr>
+          <a:xfrm rot="10800000" flipH="1">
+            <a:off x="3586908" y="1920284"/>
+            <a:ext cx="756300" cy="1972800"/>
+          </a:xfrm>
+          <a:prstGeom prst="straightConnector1">
+            <a:avLst/>
+          </a:prstGeom>
+          <a:noFill/>
+          <a:ln w="9525" cap="flat" cmpd="sng">
+            <a:solidFill>
+              <a:srgbClr val="595959"/>
+            </a:solidFill>
+            <a:prstDash val="solid"/>
+            <a:round/>
+            <a:headEnd type="none" w="med" len="med"/>
+            <a:tailEnd type="triangle" w="med" len="med"/>
+          </a:ln>
+        </p:spPr>
+      </p:cxnSp>
+      <p:cxnSp>
+        <p:nvCxnSpPr>
+          <p:cNvPr id="572" name="Google Shape;572;p25"/>
+          <p:cNvCxnSpPr>
+            <a:stCxn id="521" idx="6"/>
+            <a:endCxn id="523" idx="2"/>
+          </p:cNvCxnSpPr>
+          <p:nvPr>
+            <p:custDataLst>
+              <p:tags r:id="rId32"/>
+            </p:custDataLst>
+          </p:nvPr>
+        </p:nvCxnSpPr>
+        <p:spPr>
+          <a:xfrm rot="10800000" flipH="1">
+            <a:off x="3586908" y="2684684"/>
+            <a:ext cx="756300" cy="1208400"/>
+          </a:xfrm>
+          <a:prstGeom prst="straightConnector1">
+            <a:avLst/>
+          </a:prstGeom>
+          <a:noFill/>
+          <a:ln w="9525" cap="flat" cmpd="sng">
+            <a:solidFill>
+              <a:srgbClr val="595959"/>
+            </a:solidFill>
+            <a:prstDash val="solid"/>
+            <a:round/>
+            <a:headEnd type="none" w="med" len="med"/>
+            <a:tailEnd type="triangle" w="med" len="med"/>
+          </a:ln>
+        </p:spPr>
+      </p:cxnSp>
+      <p:cxnSp>
+        <p:nvCxnSpPr>
+          <p:cNvPr id="573" name="Google Shape;573;p25"/>
+          <p:cNvCxnSpPr>
+            <a:stCxn id="521" idx="6"/>
+            <a:endCxn id="524" idx="2"/>
+          </p:cNvCxnSpPr>
+          <p:nvPr>
+            <p:custDataLst>
+              <p:tags r:id="rId33"/>
+            </p:custDataLst>
+          </p:nvPr>
+        </p:nvCxnSpPr>
+        <p:spPr>
+          <a:xfrm>
+            <a:off x="3586908" y="3893084"/>
+            <a:ext cx="756300" cy="0"/>
+          </a:xfrm>
+          <a:prstGeom prst="straightConnector1">
+            <a:avLst/>
+          </a:prstGeom>
+          <a:noFill/>
+          <a:ln w="9525" cap="flat" cmpd="sng">
+            <a:solidFill>
+              <a:srgbClr val="595959"/>
+            </a:solidFill>
+            <a:prstDash val="solid"/>
+            <a:round/>
+            <a:headEnd type="none" w="med" len="med"/>
+            <a:tailEnd type="triangle" w="med" len="med"/>
+          </a:ln>
+        </p:spPr>
+      </p:cxnSp>
+      <p:cxnSp>
+        <p:nvCxnSpPr>
+          <p:cNvPr id="574" name="Google Shape;574;p25"/>
+          <p:cNvCxnSpPr/>
+          <p:nvPr>
+            <p:custDataLst>
+              <p:tags r:id="rId34"/>
+            </p:custDataLst>
+          </p:nvPr>
+        </p:nvCxnSpPr>
+        <p:spPr>
+          <a:xfrm>
+            <a:off x="4936408" y="1091391"/>
+            <a:ext cx="750300" cy="0"/>
+          </a:xfrm>
+          <a:prstGeom prst="straightConnector1">
+            <a:avLst/>
+          </a:prstGeom>
+          <a:noFill/>
+          <a:ln w="9525" cap="flat" cmpd="sng">
+            <a:solidFill>
+              <a:srgbClr val="595959"/>
+            </a:solidFill>
+            <a:prstDash val="solid"/>
+            <a:round/>
+            <a:headEnd type="none" w="med" len="med"/>
+            <a:tailEnd type="triangle" w="med" len="med"/>
+          </a:ln>
+        </p:spPr>
+      </p:cxnSp>
+      <p:cxnSp>
+        <p:nvCxnSpPr>
+          <p:cNvPr id="575" name="Google Shape;575;p25"/>
+          <p:cNvCxnSpPr/>
+          <p:nvPr>
+            <p:custDataLst>
+              <p:tags r:id="rId35"/>
+            </p:custDataLst>
+          </p:nvPr>
+        </p:nvCxnSpPr>
+        <p:spPr>
+          <a:xfrm>
+            <a:off x="4936408" y="1091391"/>
+            <a:ext cx="750300" cy="811200"/>
+          </a:xfrm>
+          <a:prstGeom prst="straightConnector1">
+            <a:avLst/>
+          </a:prstGeom>
+          <a:noFill/>
+          <a:ln w="9525" cap="flat" cmpd="sng">
+            <a:solidFill>
+              <a:srgbClr val="595959"/>
+            </a:solidFill>
+            <a:prstDash val="solid"/>
+            <a:round/>
+            <a:headEnd type="none" w="med" len="med"/>
+            <a:tailEnd type="triangle" w="med" len="med"/>
+          </a:ln>
+        </p:spPr>
+      </p:cxnSp>
+      <p:cxnSp>
+        <p:nvCxnSpPr>
+          <p:cNvPr id="576" name="Google Shape;576;p25"/>
+          <p:cNvCxnSpPr/>
+          <p:nvPr>
+            <p:custDataLst>
+              <p:tags r:id="rId36"/>
+            </p:custDataLst>
+          </p:nvPr>
+        </p:nvCxnSpPr>
+        <p:spPr>
+          <a:xfrm>
+            <a:off x="4936408" y="1091391"/>
+            <a:ext cx="750300" cy="1575600"/>
+          </a:xfrm>
+          <a:prstGeom prst="straightConnector1">
+            <a:avLst/>
+          </a:prstGeom>
+          <a:noFill/>
+          <a:ln w="9525" cap="flat" cmpd="sng">
+            <a:solidFill>
+              <a:srgbClr val="595959"/>
+            </a:solidFill>
+            <a:prstDash val="solid"/>
+            <a:round/>
+            <a:headEnd type="none" w="med" len="med"/>
+            <a:tailEnd type="triangle" w="med" len="med"/>
+          </a:ln>
+        </p:spPr>
+      </p:cxnSp>
+      <p:cxnSp>
+        <p:nvCxnSpPr>
+          <p:cNvPr id="577" name="Google Shape;577;p25"/>
+          <p:cNvCxnSpPr/>
+          <p:nvPr>
+            <p:custDataLst>
+              <p:tags r:id="rId37"/>
+            </p:custDataLst>
+          </p:nvPr>
+        </p:nvCxnSpPr>
+        <p:spPr>
+          <a:xfrm>
+            <a:off x="4936408" y="1091391"/>
+            <a:ext cx="750300" cy="2784000"/>
+          </a:xfrm>
+          <a:prstGeom prst="straightConnector1">
+            <a:avLst/>
+          </a:prstGeom>
+          <a:noFill/>
+          <a:ln w="9525" cap="flat" cmpd="sng">
+            <a:solidFill>
+              <a:srgbClr val="595959"/>
+            </a:solidFill>
+            <a:prstDash val="solid"/>
+            <a:round/>
+            <a:headEnd type="none" w="med" len="med"/>
+            <a:tailEnd type="triangle" w="med" len="med"/>
+          </a:ln>
+        </p:spPr>
+      </p:cxnSp>
+      <p:cxnSp>
+        <p:nvCxnSpPr>
+          <p:cNvPr id="578" name="Google Shape;578;p25"/>
+          <p:cNvCxnSpPr/>
+          <p:nvPr>
+            <p:custDataLst>
+              <p:tags r:id="rId38"/>
+            </p:custDataLst>
+          </p:nvPr>
+        </p:nvCxnSpPr>
+        <p:spPr>
+          <a:xfrm rot="10800000" flipH="1">
+            <a:off x="5063408" y="1218513"/>
+            <a:ext cx="750300" cy="811200"/>
+          </a:xfrm>
+          <a:prstGeom prst="straightConnector1">
+            <a:avLst/>
+          </a:prstGeom>
+          <a:noFill/>
+          <a:ln w="9525" cap="flat" cmpd="sng">
+            <a:solidFill>
+              <a:srgbClr val="595959"/>
+            </a:solidFill>
+            <a:prstDash val="solid"/>
+            <a:round/>
+            <a:headEnd type="none" w="med" len="med"/>
+            <a:tailEnd type="triangle" w="med" len="med"/>
+          </a:ln>
+        </p:spPr>
+      </p:cxnSp>
+      <p:cxnSp>
+        <p:nvCxnSpPr>
+          <p:cNvPr id="579" name="Google Shape;579;p25"/>
+          <p:cNvCxnSpPr/>
+          <p:nvPr>
+            <p:custDataLst>
+              <p:tags r:id="rId39"/>
+            </p:custDataLst>
+          </p:nvPr>
+        </p:nvCxnSpPr>
+        <p:spPr>
+          <a:xfrm>
+            <a:off x="4936408" y="1902713"/>
+            <a:ext cx="750300" cy="0"/>
+          </a:xfrm>
+          <a:prstGeom prst="straightConnector1">
+            <a:avLst/>
+          </a:prstGeom>
+          <a:noFill/>
+          <a:ln w="9525" cap="flat" cmpd="sng">
+            <a:solidFill>
+              <a:srgbClr val="595959"/>
+            </a:solidFill>
+            <a:prstDash val="solid"/>
+            <a:round/>
+            <a:headEnd type="none" w="med" len="med"/>
+            <a:tailEnd type="triangle" w="med" len="med"/>
+          </a:ln>
+        </p:spPr>
+      </p:cxnSp>
+      <p:cxnSp>
+        <p:nvCxnSpPr>
+          <p:cNvPr id="580" name="Google Shape;580;p25"/>
+          <p:cNvCxnSpPr/>
+          <p:nvPr>
+            <p:custDataLst>
+              <p:tags r:id="rId40"/>
+            </p:custDataLst>
+          </p:nvPr>
+        </p:nvCxnSpPr>
+        <p:spPr>
+          <a:xfrm>
+            <a:off x="4936408" y="1902713"/>
+            <a:ext cx="750300" cy="764100"/>
+          </a:xfrm>
+          <a:prstGeom prst="straightConnector1">
+            <a:avLst/>
+          </a:prstGeom>
+          <a:noFill/>
+          <a:ln w="9525" cap="flat" cmpd="sng">
+            <a:solidFill>
+              <a:srgbClr val="595959"/>
+            </a:solidFill>
+            <a:prstDash val="solid"/>
+            <a:round/>
+            <a:headEnd type="none" w="med" len="med"/>
+            <a:tailEnd type="triangle" w="med" len="med"/>
+          </a:ln>
+        </p:spPr>
+      </p:cxnSp>
+      <p:cxnSp>
+        <p:nvCxnSpPr>
+          <p:cNvPr id="581" name="Google Shape;581;p25"/>
+          <p:cNvCxnSpPr/>
+          <p:nvPr>
+            <p:custDataLst>
+              <p:tags r:id="rId41"/>
+            </p:custDataLst>
+          </p:nvPr>
+        </p:nvCxnSpPr>
+        <p:spPr>
+          <a:xfrm>
+            <a:off x="4936408" y="1902713"/>
+            <a:ext cx="750300" cy="1972800"/>
+          </a:xfrm>
+          <a:prstGeom prst="straightConnector1">
+            <a:avLst/>
+          </a:prstGeom>
+          <a:noFill/>
+          <a:ln w="9525" cap="flat" cmpd="sng">
+            <a:solidFill>
+              <a:srgbClr val="595959"/>
+            </a:solidFill>
+            <a:prstDash val="solid"/>
+            <a:round/>
+            <a:headEnd type="none" w="med" len="med"/>
+            <a:tailEnd type="triangle" w="med" len="med"/>
+          </a:ln>
+        </p:spPr>
+      </p:cxnSp>
+      <p:cxnSp>
+        <p:nvCxnSpPr>
+          <p:cNvPr id="582" name="Google Shape;582;p25"/>
+          <p:cNvCxnSpPr/>
+          <p:nvPr>
+            <p:custDataLst>
+              <p:tags r:id="rId42"/>
+            </p:custDataLst>
+          </p:nvPr>
+        </p:nvCxnSpPr>
+        <p:spPr>
+          <a:xfrm rot="10800000" flipH="1">
+            <a:off x="4936408" y="1091536"/>
+            <a:ext cx="750300" cy="1548300"/>
+          </a:xfrm>
+          <a:prstGeom prst="straightConnector1">
+            <a:avLst/>
+          </a:prstGeom>
+          <a:noFill/>
+          <a:ln w="9525" cap="flat" cmpd="sng">
+            <a:solidFill>
+              <a:srgbClr val="595959"/>
+            </a:solidFill>
+            <a:prstDash val="solid"/>
+            <a:round/>
+            <a:headEnd type="none" w="med" len="med"/>
+            <a:tailEnd type="triangle" w="med" len="med"/>
+          </a:ln>
+        </p:spPr>
+      </p:cxnSp>
+      <p:cxnSp>
+        <p:nvCxnSpPr>
+          <p:cNvPr id="583" name="Google Shape;583;p25"/>
+          <p:cNvCxnSpPr/>
+          <p:nvPr>
+            <p:custDataLst>
+              <p:tags r:id="rId43"/>
+            </p:custDataLst>
+          </p:nvPr>
+        </p:nvCxnSpPr>
+        <p:spPr>
+          <a:xfrm rot="10800000" flipH="1">
+            <a:off x="4936408" y="1902736"/>
+            <a:ext cx="750300" cy="737100"/>
+          </a:xfrm>
+          <a:prstGeom prst="straightConnector1">
+            <a:avLst/>
+          </a:prstGeom>
+          <a:noFill/>
+          <a:ln w="9525" cap="flat" cmpd="sng">
+            <a:solidFill>
+              <a:srgbClr val="595959"/>
+            </a:solidFill>
+            <a:prstDash val="solid"/>
+            <a:round/>
+            <a:headEnd type="none" w="med" len="med"/>
+            <a:tailEnd type="triangle" w="med" len="med"/>
+          </a:ln>
+        </p:spPr>
+      </p:cxnSp>
+      <p:cxnSp>
+        <p:nvCxnSpPr>
+          <p:cNvPr id="584" name="Google Shape;584;p25"/>
+          <p:cNvCxnSpPr/>
+          <p:nvPr>
+            <p:custDataLst>
+              <p:tags r:id="rId44"/>
+            </p:custDataLst>
+          </p:nvPr>
+        </p:nvCxnSpPr>
+        <p:spPr>
+          <a:xfrm>
+            <a:off x="4936408" y="2639836"/>
+            <a:ext cx="750300" cy="27000"/>
+          </a:xfrm>
+          <a:prstGeom prst="straightConnector1">
+            <a:avLst/>
+          </a:prstGeom>
+          <a:noFill/>
+          <a:ln w="9525" cap="flat" cmpd="sng">
+            <a:solidFill>
+              <a:srgbClr val="595959"/>
+            </a:solidFill>
+            <a:prstDash val="solid"/>
+            <a:round/>
+            <a:headEnd type="none" w="med" len="med"/>
+            <a:tailEnd type="triangle" w="med" len="med"/>
+          </a:ln>
+        </p:spPr>
+      </p:cxnSp>
+      <p:cxnSp>
+        <p:nvCxnSpPr>
+          <p:cNvPr id="585" name="Google Shape;585;p25"/>
+          <p:cNvCxnSpPr/>
+          <p:nvPr>
+            <p:custDataLst>
+              <p:tags r:id="rId45"/>
+            </p:custDataLst>
+          </p:nvPr>
+        </p:nvCxnSpPr>
+        <p:spPr>
+          <a:xfrm>
+            <a:off x="4936408" y="2639836"/>
+            <a:ext cx="750300" cy="1235400"/>
+          </a:xfrm>
+          <a:prstGeom prst="straightConnector1">
+            <a:avLst/>
+          </a:prstGeom>
+          <a:noFill/>
+          <a:ln w="9525" cap="flat" cmpd="sng">
+            <a:solidFill>
+              <a:srgbClr val="595959"/>
+            </a:solidFill>
+            <a:prstDash val="solid"/>
+            <a:round/>
+            <a:headEnd type="none" w="med" len="med"/>
+            <a:tailEnd type="triangle" w="med" len="med"/>
+          </a:ln>
+        </p:spPr>
+      </p:cxnSp>
+      <p:cxnSp>
+        <p:nvCxnSpPr>
+          <p:cNvPr id="586" name="Google Shape;586;p25"/>
+          <p:cNvCxnSpPr/>
+          <p:nvPr>
+            <p:custDataLst>
+              <p:tags r:id="rId46"/>
+            </p:custDataLst>
+          </p:nvPr>
+        </p:nvCxnSpPr>
+        <p:spPr>
+          <a:xfrm rot="10800000" flipH="1">
+            <a:off x="4936308" y="1091391"/>
+            <a:ext cx="750300" cy="2819400"/>
+          </a:xfrm>
+          <a:prstGeom prst="straightConnector1">
+            <a:avLst/>
+          </a:prstGeom>
+          <a:noFill/>
+          <a:ln w="9525" cap="flat" cmpd="sng">
+            <a:solidFill>
+              <a:srgbClr val="595959"/>
+            </a:solidFill>
+            <a:prstDash val="solid"/>
+            <a:round/>
+            <a:headEnd type="none" w="med" len="med"/>
+            <a:tailEnd type="triangle" w="med" len="med"/>
+          </a:ln>
+        </p:spPr>
+      </p:cxnSp>
+      <p:cxnSp>
+        <p:nvCxnSpPr>
+          <p:cNvPr id="587" name="Google Shape;587;p25"/>
+          <p:cNvCxnSpPr/>
+          <p:nvPr>
+            <p:custDataLst>
+              <p:tags r:id="rId47"/>
+            </p:custDataLst>
+          </p:nvPr>
+        </p:nvCxnSpPr>
+        <p:spPr>
+          <a:xfrm rot="10800000" flipH="1">
+            <a:off x="5063408" y="2029584"/>
+            <a:ext cx="750300" cy="1972800"/>
+          </a:xfrm>
+          <a:prstGeom prst="straightConnector1">
+            <a:avLst/>
+          </a:prstGeom>
+          <a:noFill/>
+          <a:ln w="9525" cap="flat" cmpd="sng">
+            <a:solidFill>
+              <a:srgbClr val="595959"/>
+            </a:solidFill>
+            <a:prstDash val="solid"/>
+            <a:round/>
+            <a:headEnd type="none" w="med" len="med"/>
+            <a:tailEnd type="triangle" w="med" len="med"/>
+          </a:ln>
+        </p:spPr>
+      </p:cxnSp>
+      <p:cxnSp>
+        <p:nvCxnSpPr>
+          <p:cNvPr id="588" name="Google Shape;588;p25"/>
+          <p:cNvCxnSpPr/>
+          <p:nvPr>
+            <p:custDataLst>
+              <p:tags r:id="rId48"/>
+            </p:custDataLst>
+          </p:nvPr>
+        </p:nvCxnSpPr>
+        <p:spPr>
+          <a:xfrm rot="10800000" flipH="1">
+            <a:off x="4936408" y="2666984"/>
+            <a:ext cx="750300" cy="1208400"/>
+          </a:xfrm>
+          <a:prstGeom prst="straightConnector1">
+            <a:avLst/>
+          </a:prstGeom>
+          <a:noFill/>
+          <a:ln w="9525" cap="flat" cmpd="sng">
+            <a:solidFill>
+              <a:srgbClr val="595959"/>
+            </a:solidFill>
+            <a:prstDash val="solid"/>
+            <a:round/>
+            <a:headEnd type="none" w="med" len="med"/>
+            <a:tailEnd type="triangle" w="med" len="med"/>
+          </a:ln>
+        </p:spPr>
+      </p:cxnSp>
+      <p:cxnSp>
+        <p:nvCxnSpPr>
+          <p:cNvPr id="589" name="Google Shape;589;p25"/>
+          <p:cNvCxnSpPr/>
+          <p:nvPr>
+            <p:custDataLst>
+              <p:tags r:id="rId49"/>
+            </p:custDataLst>
+          </p:nvPr>
+        </p:nvCxnSpPr>
+        <p:spPr>
+          <a:xfrm>
+            <a:off x="4936408" y="3875384"/>
+            <a:ext cx="750300" cy="0"/>
+          </a:xfrm>
+          <a:prstGeom prst="straightConnector1">
+            <a:avLst/>
+          </a:prstGeom>
+          <a:noFill/>
+          <a:ln w="9525" cap="flat" cmpd="sng">
+            <a:solidFill>
+              <a:srgbClr val="595959"/>
+            </a:solidFill>
+            <a:prstDash val="solid"/>
+            <a:round/>
+            <a:headEnd type="none" w="med" len="med"/>
+            <a:tailEnd type="triangle" w="med" len="med"/>
+          </a:ln>
+        </p:spPr>
+      </p:cxnSp>
+      <p:cxnSp>
+        <p:nvCxnSpPr>
+          <p:cNvPr id="593" name="Google Shape;593;p25"/>
+          <p:cNvCxnSpPr/>
+          <p:nvPr>
+            <p:custDataLst>
+              <p:tags r:id="rId50"/>
+            </p:custDataLst>
+          </p:nvPr>
+        </p:nvCxnSpPr>
+        <p:spPr>
+          <a:xfrm flipH="1">
+            <a:off x="4636700" y="3088775"/>
+            <a:ext cx="6000" cy="450000"/>
+          </a:xfrm>
+          <a:prstGeom prst="straightConnector1">
+            <a:avLst/>
+          </a:prstGeom>
+          <a:noFill/>
+          <a:ln w="28575" cap="flat" cmpd="sng">
+            <a:solidFill>
+              <a:srgbClr val="595959"/>
+            </a:solidFill>
+            <a:prstDash val="dot"/>
+            <a:round/>
+            <a:headEnd type="none" w="med" len="med"/>
+            <a:tailEnd type="none" w="med" len="med"/>
+          </a:ln>
+        </p:spPr>
+      </p:cxnSp>
+      <p:cxnSp>
+        <p:nvCxnSpPr>
+          <p:cNvPr id="594" name="Google Shape;594;p25"/>
+          <p:cNvCxnSpPr/>
+          <p:nvPr>
+            <p:custDataLst>
+              <p:tags r:id="rId51"/>
+            </p:custDataLst>
+          </p:nvPr>
+        </p:nvCxnSpPr>
+        <p:spPr>
+          <a:xfrm flipH="1">
+            <a:off x="5980300" y="3088763"/>
+            <a:ext cx="6000" cy="450000"/>
+          </a:xfrm>
+          <a:prstGeom prst="straightConnector1">
+            <a:avLst/>
+          </a:prstGeom>
+          <a:noFill/>
+          <a:ln w="28575" cap="flat" cmpd="sng">
+            <a:solidFill>
+              <a:srgbClr val="595959"/>
+            </a:solidFill>
+            <a:prstDash val="dot"/>
+            <a:round/>
+            <a:headEnd type="none" w="med" len="med"/>
+            <a:tailEnd type="none" w="med" len="med"/>
+          </a:ln>
+        </p:spPr>
+      </p:cxnSp>
+      <p:sp>
+        <p:nvSpPr>
+          <p:cNvPr id="6" name="Google Shape;515;p25"/>
+          <p:cNvSpPr/>
+          <p:nvPr>
+            <p:custDataLst>
+              <p:tags r:id="rId52"/>
+            </p:custDataLst>
+          </p:nvPr>
+        </p:nvSpPr>
+        <p:spPr>
+          <a:xfrm>
+            <a:off x="10324948" y="2200241"/>
+            <a:ext cx="593100" cy="611700"/>
+          </a:xfrm>
+          <a:prstGeom prst="ellipse">
+            <a:avLst/>
+          </a:prstGeom>
+          <a:gradFill>
+            <a:gsLst>
+              <a:gs pos="0">
+                <a:srgbClr val="E0EDBA">
+                  <a:alpha val="79215"/>
+                </a:srgbClr>
+              </a:gs>
+              <a:gs pos="100000">
+                <a:srgbClr val="DE87F1">
+                  <a:alpha val="39607"/>
+                </a:srgbClr>
+              </a:gs>
+            </a:gsLst>
+            <a:lin ang="13500032" scaled="0"/>
+          </a:gradFill>
+          <a:ln w="9525" cap="flat" cmpd="sng">
+            <a:solidFill>
+              <a:srgbClr val="595959"/>
+            </a:solidFill>
+            <a:prstDash val="solid"/>
+            <a:round/>
+            <a:headEnd type="none" w="sm" len="sm"/>
+            <a:tailEnd type="none" w="sm" len="sm"/>
+          </a:ln>
+        </p:spPr>
+        <p:txBody>
+          <a:bodyPr spcFirstLastPara="1" wrap="square" lIns="91425" tIns="91425" rIns="91425" bIns="91425" anchor="ctr" anchorCtr="0">
+            <a:noAutofit/>
+          </a:bodyPr>
+          <a:p>
+            <a:pPr marL="0" lvl="0" indent="0" algn="l" rtl="0">
+              <a:spcBef>
+                <a:spcPts val="0"/>
+              </a:spcBef>
+              <a:spcAft>
+                <a:spcPts val="0"/>
+              </a:spcAft>
+              <a:buClr>
+                <a:srgbClr val="000000"/>
+              </a:buClr>
+              <a:buSzPts val="1100"/>
+              <a:buFont typeface="Arial" panose="020B0704020202020204"/>
+              <a:buNone/>
+            </a:pPr>
+            <a:r>
+              <a:rPr lang="en-GB" sz="1100">
+                <a:solidFill>
+                  <a:srgbClr val="000000"/>
+                </a:solidFill>
+              </a:rPr>
+              <a:t>a</a:t>
+            </a:r>
+            <a:r>
+              <a:rPr lang="en-GB" sz="1100" baseline="30000">
+                <a:solidFill>
+                  <a:srgbClr val="000000"/>
+                </a:solidFill>
+              </a:rPr>
+              <a:t>[3]</a:t>
+            </a:r>
+            <a:r>
+              <a:rPr lang="en-GB" sz="1100" baseline="-25000">
+                <a:solidFill>
+                  <a:srgbClr val="000000"/>
+                </a:solidFill>
+              </a:rPr>
+              <a:t>1</a:t>
+            </a:r>
+            <a:endParaRPr sz="1200" baseline="-25000"/>
+          </a:p>
+        </p:txBody>
+      </p:sp>
+      <p:pic>
+        <p:nvPicPr>
+          <p:cNvPr id="7" name="图片 6"/>
+          <p:cNvPicPr>
+            <a:picLocks noChangeAspect="1"/>
+          </p:cNvPicPr>
+          <p:nvPr>
+            <p:custDataLst>
+              <p:tags r:id="rId53"/>
+            </p:custDataLst>
+          </p:nvPr>
+        </p:nvPicPr>
+        <p:blipFill>
+          <a:blip r:embed="rId4"/>
+          <a:stretch>
+            <a:fillRect/>
+          </a:stretch>
+        </p:blipFill>
+        <p:spPr>
+          <a:xfrm>
+            <a:off x="355600" y="4445000"/>
+            <a:ext cx="1689100" cy="1689100"/>
+          </a:xfrm>
+          <a:prstGeom prst="rect">
+            <a:avLst/>
+          </a:prstGeom>
+        </p:spPr>
+      </p:pic>
+      <p:sp>
+        <p:nvSpPr>
+          <p:cNvPr id="9" name="文本框 8"/>
+          <p:cNvSpPr txBox="1"/>
+          <p:nvPr>
+            <p:custDataLst>
+              <p:tags r:id="rId54"/>
+            </p:custDataLst>
+          </p:nvPr>
+        </p:nvSpPr>
+        <p:spPr>
+          <a:xfrm>
+            <a:off x="785495" y="3429000"/>
+            <a:ext cx="1259205" cy="322580"/>
+          </a:xfrm>
+          <a:prstGeom prst="rect">
+            <a:avLst/>
+          </a:prstGeom>
+          <a:noFill/>
+        </p:spPr>
+        <p:txBody>
+          <a:bodyPr wrap="square" rtlCol="0">
+            <a:noAutofit/>
+          </a:bodyPr>
+          <a:p>
+            <a:pPr algn="ctr"/>
+            <a:r>
+              <a:rPr lang="zh-CN" altLang="en-US" sz="1200" b="1">
+                <a:latin typeface="微软雅黑" charset="0"/>
+                <a:ea typeface="微软雅黑" charset="0"/>
+                <a:cs typeface="微软雅黑" charset="0"/>
+              </a:rPr>
+              <a:t>初始</a:t>
+            </a:r>
+            <a:r>
+              <a:rPr lang="zh-CN" altLang="en-US" sz="1200" b="1">
+                <a:latin typeface="微软雅黑" charset="0"/>
+                <a:ea typeface="微软雅黑" charset="0"/>
+                <a:cs typeface="微软雅黑" charset="0"/>
+              </a:rPr>
+              <a:t>图像</a:t>
+            </a:r>
+            <a:endParaRPr lang="zh-CN" altLang="en-US" sz="1200" b="1">
+              <a:latin typeface="微软雅黑" charset="0"/>
+              <a:ea typeface="微软雅黑" charset="0"/>
+              <a:cs typeface="微软雅黑" charset="0"/>
+            </a:endParaRPr>
+          </a:p>
+        </p:txBody>
+      </p:sp>
+      <p:sp>
+        <p:nvSpPr>
+          <p:cNvPr id="10" name="文本框 9"/>
+          <p:cNvSpPr txBox="1"/>
+          <p:nvPr>
+            <p:custDataLst>
+              <p:tags r:id="rId55"/>
+            </p:custDataLst>
+          </p:nvPr>
+        </p:nvSpPr>
+        <p:spPr>
+          <a:xfrm>
+            <a:off x="3994785" y="4445000"/>
+            <a:ext cx="1556385" cy="322580"/>
+          </a:xfrm>
+          <a:prstGeom prst="rect">
+            <a:avLst/>
+          </a:prstGeom>
+          <a:noFill/>
+        </p:spPr>
+        <p:txBody>
+          <a:bodyPr wrap="square" rtlCol="0">
+            <a:noAutofit/>
+          </a:bodyPr>
+          <a:p>
+            <a:pPr algn="ctr"/>
+            <a:r>
+              <a:rPr lang="zh-CN" altLang="en-US" sz="1200" b="1">
+                <a:latin typeface="微软雅黑" charset="0"/>
+                <a:ea typeface="微软雅黑" charset="0"/>
+                <a:cs typeface="微软雅黑" charset="0"/>
+              </a:rPr>
+              <a:t>训练好的</a:t>
+            </a:r>
+            <a:r>
+              <a:rPr lang="zh-CN" altLang="en-US" sz="1200" b="1">
+                <a:latin typeface="微软雅黑" charset="0"/>
+                <a:ea typeface="微软雅黑" charset="0"/>
+                <a:cs typeface="微软雅黑" charset="0"/>
+              </a:rPr>
+              <a:t>分类网络</a:t>
+            </a:r>
+            <a:endParaRPr lang="zh-CN" altLang="en-US" sz="1200" b="1">
+              <a:latin typeface="微软雅黑" charset="0"/>
+              <a:ea typeface="微软雅黑" charset="0"/>
+              <a:cs typeface="微软雅黑" charset="0"/>
+            </a:endParaRPr>
+          </a:p>
+        </p:txBody>
+      </p:sp>
+      <p:sp>
+        <p:nvSpPr>
+          <p:cNvPr id="11" name="文本框 10"/>
+          <p:cNvSpPr txBox="1"/>
+          <p:nvPr>
+            <p:custDataLst>
+              <p:tags r:id="rId56"/>
+            </p:custDataLst>
+          </p:nvPr>
+        </p:nvSpPr>
+        <p:spPr>
+          <a:xfrm>
+            <a:off x="6040120" y="3048000"/>
+            <a:ext cx="1689735" cy="322580"/>
+          </a:xfrm>
+          <a:prstGeom prst="rect">
+            <a:avLst/>
+          </a:prstGeom>
+          <a:noFill/>
+        </p:spPr>
+        <p:txBody>
+          <a:bodyPr wrap="square" rtlCol="0">
+            <a:noAutofit/>
+          </a:bodyPr>
+          <a:p>
+            <a:pPr algn="ctr"/>
+            <a:r>
+              <a:rPr lang="zh-CN" altLang="en-US" sz="1200" b="1">
+                <a:latin typeface="微软雅黑" charset="0"/>
+                <a:ea typeface="微软雅黑" charset="0"/>
+                <a:cs typeface="微软雅黑" charset="0"/>
+              </a:rPr>
+              <a:t>训练好的分类网络输出每个类别的</a:t>
+            </a:r>
+            <a:r>
+              <a:rPr lang="zh-CN" altLang="en-US" sz="1200" b="1">
+                <a:latin typeface="微软雅黑" charset="0"/>
+                <a:ea typeface="微软雅黑" charset="0"/>
+                <a:cs typeface="微软雅黑" charset="0"/>
+              </a:rPr>
+              <a:t>概率</a:t>
+            </a:r>
+            <a:endParaRPr lang="zh-CN" altLang="en-US" sz="1200" b="1">
+              <a:latin typeface="微软雅黑" charset="0"/>
+              <a:ea typeface="微软雅黑" charset="0"/>
+              <a:cs typeface="微软雅黑" charset="0"/>
+            </a:endParaRPr>
+          </a:p>
+        </p:txBody>
+      </p:sp>
+      <p:sp>
+        <p:nvSpPr>
+          <p:cNvPr id="12" name="文本框 11"/>
+          <p:cNvSpPr txBox="1"/>
+          <p:nvPr>
+            <p:custDataLst>
+              <p:tags r:id="rId57"/>
+            </p:custDataLst>
+          </p:nvPr>
+        </p:nvSpPr>
+        <p:spPr>
+          <a:xfrm>
+            <a:off x="9018905" y="3048000"/>
+            <a:ext cx="1689735" cy="322580"/>
+          </a:xfrm>
+          <a:prstGeom prst="rect">
+            <a:avLst/>
+          </a:prstGeom>
+          <a:noFill/>
+        </p:spPr>
+        <p:txBody>
+          <a:bodyPr wrap="square" rtlCol="0">
+            <a:noAutofit/>
+          </a:bodyPr>
+          <a:p>
+            <a:pPr algn="ctr"/>
+            <a:r>
+              <a:rPr lang="zh-CN" altLang="en-US" sz="1200" b="1">
+                <a:latin typeface="微软雅黑" charset="0"/>
+                <a:ea typeface="微软雅黑" charset="0"/>
+                <a:cs typeface="微软雅黑" charset="0"/>
+              </a:rPr>
+              <a:t>正确</a:t>
+            </a:r>
+            <a:r>
+              <a:rPr lang="zh-CN" altLang="en-US" sz="1200" b="1">
+                <a:latin typeface="微软雅黑" charset="0"/>
+                <a:ea typeface="微软雅黑" charset="0"/>
+                <a:cs typeface="微软雅黑" charset="0"/>
+              </a:rPr>
+              <a:t>标签</a:t>
+            </a:r>
+            <a:endParaRPr lang="zh-CN" altLang="en-US" sz="1200" b="1">
+              <a:latin typeface="微软雅黑" charset="0"/>
+              <a:ea typeface="微软雅黑" charset="0"/>
+              <a:cs typeface="微软雅黑" charset="0"/>
+            </a:endParaRPr>
+          </a:p>
+        </p:txBody>
+      </p:sp>
+      <p:sp>
+        <p:nvSpPr>
+          <p:cNvPr id="13" name="左右箭头 12"/>
+          <p:cNvSpPr/>
+          <p:nvPr/>
+        </p:nvSpPr>
+        <p:spPr>
+          <a:xfrm>
+            <a:off x="6922135" y="2376170"/>
+            <a:ext cx="2914015" cy="463550"/>
+          </a:xfrm>
+          <a:prstGeom prst="leftRightArrow">
+            <a:avLst/>
+          </a:prstGeom>
+        </p:spPr>
+        <p:style>
+          <a:lnRef idx="2">
+            <a:schemeClr val="accent1">
+              <a:lumMod val="75000"/>
+            </a:schemeClr>
+          </a:lnRef>
+          <a:fillRef idx="1">
+            <a:schemeClr val="accent1"/>
+          </a:fillRef>
+          <a:effectRef idx="0">
+            <a:srgbClr val="FFFFFF"/>
+          </a:effectRef>
+          <a:fontRef idx="minor">
+            <a:schemeClr val="lt1"/>
+          </a:fontRef>
+        </p:style>
+        <p:txBody>
+          <a:bodyPr rtlCol="0" anchor="ctr"/>
+          <a:p>
+            <a:pPr algn="ctr"/>
+            <a:endParaRPr lang="zh-CN" altLang="en-US"/>
+          </a:p>
+        </p:txBody>
+      </p:sp>
+      <p:sp>
+        <p:nvSpPr>
+          <p:cNvPr id="14" name="文本框 13"/>
+          <p:cNvSpPr txBox="1"/>
+          <p:nvPr>
+            <p:custDataLst>
+              <p:tags r:id="rId58"/>
+            </p:custDataLst>
+          </p:nvPr>
+        </p:nvSpPr>
+        <p:spPr>
+          <a:xfrm>
+            <a:off x="7606030" y="2056130"/>
+            <a:ext cx="1689735" cy="322580"/>
+          </a:xfrm>
+          <a:prstGeom prst="rect">
+            <a:avLst/>
+          </a:prstGeom>
+          <a:noFill/>
+        </p:spPr>
+        <p:txBody>
+          <a:bodyPr wrap="square" rtlCol="0">
+            <a:noAutofit/>
+          </a:bodyPr>
+          <a:p>
+            <a:pPr algn="ctr"/>
+            <a:r>
+              <a:rPr lang="en-US" altLang="zh-CN" sz="1200" b="1">
+                <a:latin typeface="微软雅黑" charset="0"/>
+                <a:ea typeface="微软雅黑" charset="0"/>
+                <a:cs typeface="微软雅黑" charset="0"/>
+              </a:rPr>
+              <a:t>1.</a:t>
+            </a:r>
+            <a:r>
+              <a:rPr lang="zh-CN" altLang="en-US" sz="1200" b="1">
+                <a:latin typeface="微软雅黑" charset="0"/>
+                <a:ea typeface="微软雅黑" charset="0"/>
+                <a:cs typeface="微软雅黑" charset="0"/>
+              </a:rPr>
+              <a:t>计算</a:t>
+            </a:r>
+            <a:r>
+              <a:rPr lang="zh-CN" altLang="en-US" sz="1200" b="1">
+                <a:latin typeface="微软雅黑" charset="0"/>
+                <a:ea typeface="微软雅黑" charset="0"/>
+                <a:cs typeface="微软雅黑" charset="0"/>
+              </a:rPr>
+              <a:t>损失</a:t>
+            </a:r>
+            <a:endParaRPr lang="zh-CN" altLang="en-US" sz="1200" b="1">
+              <a:latin typeface="微软雅黑" charset="0"/>
+              <a:ea typeface="微软雅黑" charset="0"/>
+              <a:cs typeface="微软雅黑" charset="0"/>
+            </a:endParaRPr>
+          </a:p>
+        </p:txBody>
+      </p:sp>
+      <p:sp>
+        <p:nvSpPr>
+          <p:cNvPr id="17" name="文本框 16"/>
+          <p:cNvSpPr txBox="1"/>
+          <p:nvPr>
+            <p:custDataLst>
+              <p:tags r:id="rId59"/>
+            </p:custDataLst>
+          </p:nvPr>
+        </p:nvSpPr>
+        <p:spPr>
+          <a:xfrm>
+            <a:off x="8350885" y="3751580"/>
+            <a:ext cx="3841115" cy="810260"/>
+          </a:xfrm>
+          <a:prstGeom prst="rect">
+            <a:avLst/>
+          </a:prstGeom>
+          <a:noFill/>
+        </p:spPr>
+        <p:txBody>
+          <a:bodyPr wrap="square" rtlCol="0">
+            <a:noAutofit/>
+          </a:bodyPr>
+          <a:p>
+            <a:pPr algn="ctr"/>
+            <a:r>
+              <a:rPr lang="en-US" altLang="zh-CN" sz="1200" b="1">
+                <a:latin typeface="微软雅黑" charset="0"/>
+                <a:ea typeface="微软雅黑" charset="0"/>
+                <a:cs typeface="微软雅黑" charset="0"/>
+              </a:rPr>
+              <a:t>2. </a:t>
+            </a:r>
+            <a:r>
+              <a:rPr lang="zh-CN" altLang="en-US" sz="1200" b="1">
+                <a:latin typeface="微软雅黑" charset="0"/>
+                <a:ea typeface="微软雅黑" charset="0"/>
+                <a:cs typeface="微软雅黑" charset="0"/>
+              </a:rPr>
+              <a:t>根据损失计算图像的梯度</a:t>
+            </a:r>
+            <a:br>
+              <a:rPr lang="zh-CN" altLang="en-US" sz="1200" b="1">
+                <a:latin typeface="微软雅黑" charset="0"/>
+                <a:ea typeface="微软雅黑" charset="0"/>
+                <a:cs typeface="微软雅黑" charset="0"/>
+              </a:rPr>
+            </a:br>
+            <a:r>
+              <a:rPr lang="zh-CN" altLang="en-US" sz="1200" b="1">
+                <a:latin typeface="微软雅黑" charset="0"/>
+                <a:ea typeface="微软雅黑" charset="0"/>
+                <a:cs typeface="微软雅黑" charset="0"/>
+              </a:rPr>
+              <a:t>正常</a:t>
+            </a:r>
+            <a:r>
+              <a:rPr lang="en-US" altLang="zh-CN" sz="1200" b="1">
+                <a:latin typeface="微软雅黑" charset="0"/>
+                <a:ea typeface="微软雅黑" charset="0"/>
+                <a:cs typeface="微软雅黑" charset="0"/>
+              </a:rPr>
+              <a:t>:</a:t>
+            </a:r>
+            <a:r>
+              <a:rPr lang="zh-CN" altLang="en-US" sz="1200" b="1">
+                <a:latin typeface="微软雅黑" charset="0"/>
+                <a:ea typeface="微软雅黑" charset="0"/>
+                <a:cs typeface="微软雅黑" charset="0"/>
+              </a:rPr>
+              <a:t>判断图像朝那个方向更新能够让损失最小化</a:t>
+            </a:r>
+            <a:br>
+              <a:rPr lang="zh-CN" altLang="en-US" sz="1200" b="1">
+                <a:latin typeface="微软雅黑" charset="0"/>
+                <a:ea typeface="微软雅黑" charset="0"/>
+                <a:cs typeface="微软雅黑" charset="0"/>
+              </a:rPr>
+            </a:br>
+            <a:r>
+              <a:rPr lang="zh-CN" altLang="en-US" sz="1200" b="1">
+                <a:solidFill>
+                  <a:srgbClr val="C00000"/>
+                </a:solidFill>
+                <a:latin typeface="微软雅黑" charset="0"/>
+                <a:ea typeface="微软雅黑" charset="0"/>
+                <a:cs typeface="微软雅黑" charset="0"/>
+              </a:rPr>
+              <a:t>对抗扰动</a:t>
+            </a:r>
+            <a:r>
+              <a:rPr lang="en-US" altLang="zh-CN" sz="1200" b="1">
+                <a:solidFill>
+                  <a:srgbClr val="C00000"/>
+                </a:solidFill>
+                <a:latin typeface="微软雅黑" charset="0"/>
+                <a:ea typeface="微软雅黑" charset="0"/>
+                <a:cs typeface="微软雅黑" charset="0"/>
+              </a:rPr>
+              <a:t>:</a:t>
+            </a:r>
+            <a:r>
+              <a:rPr lang="zh-CN" altLang="en-US" sz="1200" b="1">
+                <a:solidFill>
+                  <a:srgbClr val="C00000"/>
+                </a:solidFill>
+                <a:latin typeface="微软雅黑" charset="0"/>
+                <a:ea typeface="微软雅黑" charset="0"/>
+                <a:cs typeface="微软雅黑" charset="0"/>
+                <a:sym typeface="+mn-ea"/>
+              </a:rPr>
+              <a:t>判断图像朝那个方向更新能够让损失最大化</a:t>
+            </a:r>
+            <a:br>
+              <a:rPr lang="zh-CN" altLang="en-US" sz="1200" b="1">
+                <a:solidFill>
+                  <a:srgbClr val="C00000"/>
+                </a:solidFill>
+                <a:latin typeface="微软雅黑" charset="0"/>
+                <a:ea typeface="微软雅黑" charset="0"/>
+                <a:cs typeface="微软雅黑" charset="0"/>
+                <a:sym typeface="+mn-ea"/>
+              </a:rPr>
+            </a:br>
+            <a:r>
+              <a:rPr lang="zh-CN" altLang="en-US" sz="1200" b="1">
+                <a:solidFill>
+                  <a:srgbClr val="C00000"/>
+                </a:solidFill>
+                <a:latin typeface="微软雅黑" charset="0"/>
+                <a:ea typeface="微软雅黑" charset="0"/>
+                <a:cs typeface="微软雅黑" charset="0"/>
+                <a:sym typeface="+mn-ea"/>
+              </a:rPr>
+              <a:t>生成噪声</a:t>
+            </a:r>
+            <a:r>
+              <a:rPr lang="zh-CN" altLang="en-US" sz="1200" b="1">
+                <a:solidFill>
+                  <a:srgbClr val="C00000"/>
+                </a:solidFill>
+                <a:latin typeface="微软雅黑" charset="0"/>
+                <a:ea typeface="微软雅黑" charset="0"/>
+                <a:cs typeface="微软雅黑" charset="0"/>
+                <a:sym typeface="+mn-ea"/>
+              </a:rPr>
+              <a:t>图像</a:t>
+            </a:r>
+            <a:endParaRPr lang="zh-CN" altLang="en-US" sz="1200" b="1">
+              <a:solidFill>
+                <a:srgbClr val="C00000"/>
+              </a:solidFill>
+              <a:latin typeface="微软雅黑" charset="0"/>
+              <a:ea typeface="微软雅黑" charset="0"/>
+              <a:cs typeface="微软雅黑" charset="0"/>
+              <a:sym typeface="+mn-ea"/>
+            </a:endParaRPr>
+          </a:p>
+        </p:txBody>
+      </p:sp>
+      <p:pic>
+        <p:nvPicPr>
+          <p:cNvPr id="18" name="图片 17"/>
+          <p:cNvPicPr>
+            <a:picLocks noChangeAspect="1"/>
+          </p:cNvPicPr>
+          <p:nvPr>
+            <p:custDataLst>
+              <p:tags r:id="rId60"/>
+            </p:custDataLst>
+          </p:nvPr>
+        </p:nvPicPr>
+        <p:blipFill>
+          <a:blip r:embed="rId61"/>
+          <a:stretch>
+            <a:fillRect/>
+          </a:stretch>
+        </p:blipFill>
+        <p:spPr>
+          <a:xfrm>
+            <a:off x="7593965" y="4445000"/>
+            <a:ext cx="1701800" cy="1689100"/>
+          </a:xfrm>
+          <a:prstGeom prst="rect">
+            <a:avLst/>
+          </a:prstGeom>
+        </p:spPr>
+      </p:pic>
+      <p:sp>
+        <p:nvSpPr>
+          <p:cNvPr id="19" name="左箭头 18"/>
+          <p:cNvSpPr/>
+          <p:nvPr/>
+        </p:nvSpPr>
+        <p:spPr>
+          <a:xfrm>
+            <a:off x="2592705" y="5230495"/>
+            <a:ext cx="3387725" cy="499745"/>
+          </a:xfrm>
+          <a:prstGeom prst="leftArrow">
+            <a:avLst/>
+          </a:prstGeom>
+        </p:spPr>
+        <p:style>
+          <a:lnRef idx="2">
+            <a:schemeClr val="accent1">
+              <a:lumMod val="75000"/>
+            </a:schemeClr>
+          </a:lnRef>
+          <a:fillRef idx="1">
+            <a:schemeClr val="accent1"/>
+          </a:fillRef>
+          <a:effectRef idx="0">
+            <a:srgbClr val="FFFFFF"/>
+          </a:effectRef>
+          <a:fontRef idx="minor">
+            <a:schemeClr val="lt1"/>
+          </a:fontRef>
+        </p:style>
+        <p:txBody>
+          <a:bodyPr rtlCol="0" anchor="ctr"/>
+          <a:p>
+            <a:pPr algn="ctr"/>
+            <a:endParaRPr lang="zh-CN" altLang="en-US"/>
+          </a:p>
+        </p:txBody>
+      </p:sp>
+      <p:sp>
+        <p:nvSpPr>
+          <p:cNvPr id="21" name="文本框 20"/>
+          <p:cNvSpPr txBox="1"/>
+          <p:nvPr/>
+        </p:nvSpPr>
+        <p:spPr>
+          <a:xfrm>
+            <a:off x="6802755" y="5104765"/>
+            <a:ext cx="606425" cy="706755"/>
+          </a:xfrm>
+          <a:prstGeom prst="rect">
+            <a:avLst/>
+          </a:prstGeom>
+          <a:noFill/>
+        </p:spPr>
+        <p:txBody>
+          <a:bodyPr wrap="square" rtlCol="0">
+            <a:spAutoFit/>
+          </a:bodyPr>
+          <a:p>
+            <a:pPr algn="ctr"/>
+            <a:r>
+              <a:rPr lang="en-US" altLang="zh-CN" sz="4000" b="1">
+                <a:latin typeface="Times New Roman Bold" panose="02020603050405020304" charset="0"/>
+                <a:cs typeface="Times New Roman Bold" panose="02020603050405020304" charset="0"/>
+              </a:rPr>
+              <a:t>*</a:t>
+            </a:r>
+            <a:endParaRPr lang="en-US" altLang="zh-CN" sz="4000" b="1">
+              <a:latin typeface="Times New Roman Bold" panose="02020603050405020304" charset="0"/>
+              <a:cs typeface="Times New Roman Bold" panose="02020603050405020304" charset="0"/>
+            </a:endParaRPr>
+          </a:p>
+        </p:txBody>
+      </p:sp>
+      <p:sp>
+        <p:nvSpPr>
+          <p:cNvPr id="22" name="文本框 21"/>
+          <p:cNvSpPr txBox="1"/>
+          <p:nvPr>
+            <p:custDataLst>
+              <p:tags r:id="rId62"/>
+            </p:custDataLst>
+          </p:nvPr>
+        </p:nvSpPr>
+        <p:spPr>
+          <a:xfrm>
+            <a:off x="3143885" y="5783580"/>
+            <a:ext cx="3841115" cy="810260"/>
+          </a:xfrm>
+          <a:prstGeom prst="rect">
+            <a:avLst/>
+          </a:prstGeom>
+          <a:noFill/>
+        </p:spPr>
+        <p:txBody>
+          <a:bodyPr wrap="square" rtlCol="0">
+            <a:noAutofit/>
+          </a:bodyPr>
+          <a:p>
+            <a:pPr algn="ctr"/>
+            <a:r>
+              <a:rPr lang="en-US" altLang="zh-CN" sz="1200" b="1">
+                <a:solidFill>
+                  <a:schemeClr val="tx1"/>
+                </a:solidFill>
+                <a:latin typeface="微软雅黑" charset="0"/>
+                <a:ea typeface="微软雅黑" charset="0"/>
+                <a:cs typeface="微软雅黑" charset="0"/>
+                <a:sym typeface="+mn-ea"/>
+              </a:rPr>
+              <a:t>3.</a:t>
+            </a:r>
+            <a:r>
+              <a:rPr lang="zh-CN" altLang="en-US" sz="1200" b="1">
+                <a:solidFill>
+                  <a:schemeClr val="tx1"/>
+                </a:solidFill>
+                <a:latin typeface="微软雅黑" charset="0"/>
+                <a:ea typeface="微软雅黑" charset="0"/>
+                <a:cs typeface="微软雅黑" charset="0"/>
+                <a:sym typeface="+mn-ea"/>
+              </a:rPr>
+              <a:t>按照𝜀</a:t>
+            </a:r>
+            <a:r>
+              <a:rPr lang="en-US" altLang="zh-CN" sz="1200" b="1">
+                <a:solidFill>
+                  <a:schemeClr val="tx1"/>
+                </a:solidFill>
+                <a:latin typeface="微软雅黑" charset="0"/>
+                <a:ea typeface="微软雅黑" charset="0"/>
+                <a:cs typeface="微软雅黑" charset="0"/>
+                <a:sym typeface="+mn-ea"/>
+              </a:rPr>
+              <a:t> </a:t>
+            </a:r>
+            <a:r>
+              <a:rPr lang="zh-CN" altLang="en-US" sz="1200" b="1">
+                <a:solidFill>
+                  <a:schemeClr val="tx1"/>
+                </a:solidFill>
+                <a:latin typeface="微软雅黑" charset="0"/>
+                <a:ea typeface="微软雅黑" charset="0"/>
+                <a:cs typeface="微软雅黑" charset="0"/>
+                <a:sym typeface="+mn-ea"/>
+              </a:rPr>
+              <a:t>的比例将生成的噪声加到原图</a:t>
+            </a:r>
+            <a:r>
+              <a:rPr lang="zh-CN" altLang="en-US" sz="1200" b="1">
+                <a:solidFill>
+                  <a:schemeClr val="tx1"/>
+                </a:solidFill>
+                <a:latin typeface="微软雅黑" charset="0"/>
+                <a:ea typeface="微软雅黑" charset="0"/>
+                <a:cs typeface="微软雅黑" charset="0"/>
+                <a:sym typeface="+mn-ea"/>
+              </a:rPr>
+              <a:t>上</a:t>
+            </a:r>
+            <a:endParaRPr lang="zh-CN" altLang="en-US" sz="1200" b="1">
+              <a:solidFill>
+                <a:schemeClr val="tx1"/>
+              </a:solidFill>
+              <a:latin typeface="微软雅黑" charset="0"/>
+              <a:ea typeface="微软雅黑" charset="0"/>
+              <a:cs typeface="微软雅黑" charset="0"/>
+              <a:sym typeface="+mn-ea"/>
+            </a:endParaRPr>
+          </a:p>
+        </p:txBody>
+      </p:sp>
+      <p:pic>
+        <p:nvPicPr>
+          <p:cNvPr id="23" name="图片 22"/>
+          <p:cNvPicPr>
+            <a:picLocks noChangeAspect="1"/>
+          </p:cNvPicPr>
+          <p:nvPr>
+            <p:custDataLst>
+              <p:tags r:id="rId63"/>
+            </p:custDataLst>
+          </p:nvPr>
+        </p:nvPicPr>
+        <p:blipFill>
+          <a:blip r:embed="rId64"/>
+          <a:stretch>
+            <a:fillRect/>
+          </a:stretch>
+        </p:blipFill>
+        <p:spPr>
+          <a:xfrm>
+            <a:off x="7139940" y="523875"/>
+            <a:ext cx="3949065" cy="450215"/>
+          </a:xfrm>
+          <a:prstGeom prst="rect">
+            <a:avLst/>
+          </a:prstGeom>
+        </p:spPr>
+      </p:pic>
+    </p:spTree>
+  </p:cSld>
+  <p:clrMapOvr>
+    <a:masterClrMapping/>
+  </p:clrMapOvr>
+</p:sld>
+</file>
+
+<file path=ppt/slides/slide3.xml><?xml version="1.0" encoding="utf-8"?>
+<p:sld xmlns:a="http://schemas.openxmlformats.org/drawingml/2006/main" xmlns:r="http://schemas.openxmlformats.org/officeDocument/2006/relationships" xmlns:p="http://schemas.openxmlformats.org/presentationml/2006/main">
+  <p:cSld>
+    <p:spTree>
+      <p:nvGrpSpPr>
+        <p:cNvPr id="1" name=""/>
+        <p:cNvGrpSpPr/>
+        <p:nvPr/>
+      </p:nvGrpSpPr>
+      <p:grpSpPr/>
+      <p:sp>
+        <p:nvSpPr>
+          <p:cNvPr id="2" name="标题 1"/>
+          <p:cNvSpPr>
+            <a:spLocks noGrp="1"/>
+          </p:cNvSpPr>
+          <p:nvPr>
+            <p:ph type="ctrTitle"/>
+          </p:nvPr>
+        </p:nvSpPr>
+        <p:spPr/>
+        <p:txBody>
+          <a:bodyPr/>
+          <a:p>
+            <a:r>
+              <a:rPr lang="en-US" altLang="zh-CN"/>
+              <a:t>PGD</a:t>
+            </a:r>
+            <a:endParaRPr lang="en-US" altLang="zh-CN"/>
+          </a:p>
+        </p:txBody>
+      </p:sp>
+      <p:sp>
+        <p:nvSpPr>
+          <p:cNvPr id="3" name="副标题 2"/>
+          <p:cNvSpPr>
+            <a:spLocks noGrp="1"/>
+          </p:cNvSpPr>
+          <p:nvPr>
+            <p:ph type="subTitle" idx="1"/>
+          </p:nvPr>
+        </p:nvSpPr>
+        <p:spPr/>
+        <p:txBody>
+          <a:bodyPr/>
+          <a:p>
+            <a:endParaRPr lang="zh-CN" altLang="en-US"/>
+          </a:p>
+        </p:txBody>
+      </p:sp>
+    </p:spTree>
+  </p:cSld>
+  <p:clrMapOvr>
+    <a:masterClrMapping/>
+  </p:clrMapOvr>
+</p:sld>
+</file>
+
+<file path=ppt/slides/slide4.xml><?xml version="1.0" encoding="utf-8"?>
+<p:sld xmlns:a="http://schemas.openxmlformats.org/drawingml/2006/main" xmlns:r="http://schemas.openxmlformats.org/officeDocument/2006/relationships" xmlns:p="http://schemas.openxmlformats.org/presentationml/2006/main">
+  <p:cSld>
+    <p:spTree>
+      <p:nvGrpSpPr>
+        <p:cNvPr id="1" name=""/>
+        <p:cNvGrpSpPr/>
+        <p:nvPr/>
+      </p:nvGrpSpPr>
+      <p:grpSpPr/>
+      <p:pic>
+        <p:nvPicPr>
+          <p:cNvPr id="4" name="图片 3"/>
+          <p:cNvPicPr>
+            <a:picLocks noChangeAspect="1"/>
+          </p:cNvPicPr>
+          <p:nvPr>
+            <p:custDataLst>
+              <p:tags r:id="rId1"/>
+            </p:custDataLst>
+          </p:nvPr>
+        </p:nvPicPr>
+        <p:blipFill>
+          <a:blip r:embed="rId2"/>
+          <a:stretch>
+            <a:fillRect/>
+          </a:stretch>
+        </p:blipFill>
+        <p:spPr>
+          <a:xfrm>
+            <a:off x="6675120" y="783590"/>
+            <a:ext cx="4432300" cy="508000"/>
+          </a:xfrm>
+          <a:prstGeom prst="rect">
+            <a:avLst/>
+          </a:prstGeom>
+        </p:spPr>
+      </p:pic>
+      <p:pic>
+        <p:nvPicPr>
+          <p:cNvPr id="23" name="图片 22"/>
+          <p:cNvPicPr>
+            <a:picLocks noChangeAspect="1"/>
+          </p:cNvPicPr>
+          <p:nvPr>
+            <p:custDataLst>
+              <p:tags r:id="rId3"/>
+            </p:custDataLst>
+          </p:nvPr>
+        </p:nvPicPr>
+        <p:blipFill>
+          <a:blip r:embed="rId4"/>
+          <a:stretch>
+            <a:fillRect/>
+          </a:stretch>
+        </p:blipFill>
+        <p:spPr>
+          <a:xfrm>
+            <a:off x="324485" y="841375"/>
+            <a:ext cx="3949065" cy="450215"/>
+          </a:xfrm>
+          <a:prstGeom prst="rect">
+            <a:avLst/>
+          </a:prstGeom>
+        </p:spPr>
+      </p:pic>
+      <p:sp>
+        <p:nvSpPr>
+          <p:cNvPr id="11" name="文本框 10"/>
+          <p:cNvSpPr txBox="1"/>
+          <p:nvPr>
+            <p:custDataLst>
+              <p:tags r:id="rId5"/>
+            </p:custDataLst>
+          </p:nvPr>
+        </p:nvSpPr>
+        <p:spPr>
+          <a:xfrm>
+            <a:off x="658495" y="1823085"/>
+            <a:ext cx="3281680" cy="322580"/>
+          </a:xfrm>
+          <a:prstGeom prst="rect">
+            <a:avLst/>
+          </a:prstGeom>
+          <a:noFill/>
+        </p:spPr>
+        <p:txBody>
+          <a:bodyPr wrap="square" rtlCol="0">
+            <a:noAutofit/>
+          </a:bodyPr>
+          <a:p>
+            <a:pPr algn="ctr"/>
+            <a:r>
+              <a:rPr lang="en-US" altLang="zh-CN" sz="1200" b="1">
+                <a:latin typeface="微软雅黑" charset="0"/>
+                <a:ea typeface="微软雅黑" charset="0"/>
+                <a:cs typeface="微软雅黑" charset="0"/>
+              </a:rPr>
+              <a:t>FGSM</a:t>
+            </a:r>
+            <a:br>
+              <a:rPr lang="en-US" altLang="zh-CN" sz="1200" b="1">
+                <a:latin typeface="微软雅黑" charset="0"/>
+                <a:ea typeface="微软雅黑" charset="0"/>
+                <a:cs typeface="微软雅黑" charset="0"/>
+              </a:rPr>
+            </a:br>
+            <a:r>
+              <a:rPr lang="zh-CN" altLang="en-US" sz="1200" b="1">
+                <a:latin typeface="微软雅黑" charset="0"/>
+                <a:ea typeface="微软雅黑" charset="0"/>
+                <a:cs typeface="微软雅黑" charset="0"/>
+              </a:rPr>
+              <a:t>干净图像仅通过一次前项</a:t>
+            </a:r>
+            <a:r>
+              <a:rPr lang="en-US" altLang="zh-CN" sz="1200" b="1">
+                <a:latin typeface="微软雅黑" charset="0"/>
+                <a:ea typeface="微软雅黑" charset="0"/>
+                <a:cs typeface="微软雅黑" charset="0"/>
+              </a:rPr>
+              <a:t>-</a:t>
+            </a:r>
+            <a:r>
+              <a:rPr lang="zh-CN" altLang="en-US" sz="1200" b="1">
+                <a:latin typeface="微软雅黑" charset="0"/>
+                <a:ea typeface="微软雅黑" charset="0"/>
+                <a:cs typeface="微软雅黑" charset="0"/>
+              </a:rPr>
+              <a:t>反向过程</a:t>
+            </a:r>
+            <a:r>
+              <a:rPr lang="zh-CN" altLang="en-US" sz="1200" b="1">
+                <a:latin typeface="微软雅黑" charset="0"/>
+                <a:ea typeface="微软雅黑" charset="0"/>
+                <a:cs typeface="微软雅黑" charset="0"/>
+              </a:rPr>
+              <a:t>更新</a:t>
+            </a:r>
+            <a:endParaRPr lang="zh-CN" altLang="en-US" sz="1200" b="1">
+              <a:latin typeface="微软雅黑" charset="0"/>
+              <a:ea typeface="微软雅黑" charset="0"/>
+              <a:cs typeface="微软雅黑" charset="0"/>
+            </a:endParaRPr>
+          </a:p>
+        </p:txBody>
+      </p:sp>
+      <p:sp>
+        <p:nvSpPr>
+          <p:cNvPr id="5" name="文本框 4"/>
+          <p:cNvSpPr txBox="1"/>
+          <p:nvPr>
+            <p:custDataLst>
+              <p:tags r:id="rId6"/>
+            </p:custDataLst>
+          </p:nvPr>
+        </p:nvSpPr>
+        <p:spPr>
+          <a:xfrm>
+            <a:off x="7389495" y="1823085"/>
+            <a:ext cx="3281680" cy="322580"/>
+          </a:xfrm>
+          <a:prstGeom prst="rect">
+            <a:avLst/>
+          </a:prstGeom>
+          <a:noFill/>
+        </p:spPr>
+        <p:txBody>
+          <a:bodyPr wrap="square" rtlCol="0">
+            <a:noAutofit/>
+          </a:bodyPr>
+          <a:p>
+            <a:pPr algn="ctr"/>
+            <a:r>
+              <a:rPr lang="en-US" altLang="zh-CN" sz="1200" b="1">
+                <a:latin typeface="微软雅黑" charset="0"/>
+                <a:ea typeface="微软雅黑" charset="0"/>
+                <a:cs typeface="微软雅黑" charset="0"/>
+              </a:rPr>
+              <a:t>PGD</a:t>
+            </a:r>
+            <a:br>
+              <a:rPr lang="en-US" altLang="zh-CN" sz="1200" b="1">
+                <a:latin typeface="微软雅黑" charset="0"/>
+                <a:ea typeface="微软雅黑" charset="0"/>
+                <a:cs typeface="微软雅黑" charset="0"/>
+              </a:rPr>
+            </a:br>
+            <a:r>
+              <a:rPr lang="zh-CN" altLang="en-US" sz="1200" b="1">
+                <a:latin typeface="微软雅黑" charset="0"/>
+                <a:ea typeface="微软雅黑" charset="0"/>
+                <a:cs typeface="微软雅黑" charset="0"/>
+              </a:rPr>
+              <a:t>干净图像经过多次前项</a:t>
+            </a:r>
+            <a:r>
+              <a:rPr lang="en-US" altLang="zh-CN" sz="1200" b="1">
+                <a:latin typeface="微软雅黑" charset="0"/>
+                <a:ea typeface="微软雅黑" charset="0"/>
+                <a:cs typeface="微软雅黑" charset="0"/>
+              </a:rPr>
+              <a:t>-</a:t>
+            </a:r>
+            <a:r>
+              <a:rPr lang="zh-CN" altLang="en-US" sz="1200" b="1">
+                <a:latin typeface="微软雅黑" charset="0"/>
+                <a:ea typeface="微软雅黑" charset="0"/>
+                <a:cs typeface="微软雅黑" charset="0"/>
+              </a:rPr>
+              <a:t>反向过程更新</a:t>
+            </a:r>
+            <a:br>
+              <a:rPr lang="zh-CN" altLang="en-US" sz="1200" b="1">
+                <a:latin typeface="微软雅黑" charset="0"/>
+                <a:ea typeface="微软雅黑" charset="0"/>
+                <a:cs typeface="微软雅黑" charset="0"/>
+              </a:rPr>
+            </a:br>
+            <a:r>
+              <a:rPr lang="zh-CN" altLang="en-US" sz="1200" b="1">
+                <a:latin typeface="微软雅黑" charset="0"/>
+                <a:ea typeface="微软雅黑" charset="0"/>
+                <a:cs typeface="微软雅黑" charset="0"/>
+              </a:rPr>
+              <a:t>干净图像第一步根据噪声</a:t>
+            </a:r>
+            <a:r>
+              <a:rPr lang="en-US" altLang="zh-CN" sz="1200" b="1">
+                <a:latin typeface="微软雅黑" charset="0"/>
+                <a:ea typeface="微软雅黑" charset="0"/>
+                <a:cs typeface="微软雅黑" charset="0"/>
+              </a:rPr>
+              <a:t>y1</a:t>
+            </a:r>
+            <a:r>
+              <a:rPr lang="zh-CN" altLang="en-US" sz="1200" b="1">
+                <a:latin typeface="微软雅黑" charset="0"/>
+                <a:ea typeface="微软雅黑" charset="0"/>
+                <a:cs typeface="微软雅黑" charset="0"/>
+              </a:rPr>
+              <a:t>生成对抗图像</a:t>
+            </a:r>
+            <a:r>
+              <a:rPr lang="en-US" altLang="zh-CN" sz="1200" b="1">
+                <a:latin typeface="微软雅黑" charset="0"/>
+                <a:ea typeface="微软雅黑" charset="0"/>
+                <a:cs typeface="微软雅黑" charset="0"/>
+              </a:rPr>
+              <a:t>x1</a:t>
+            </a:r>
+            <a:br>
+              <a:rPr lang="en-US" altLang="zh-CN" sz="1200" b="1">
+                <a:latin typeface="微软雅黑" charset="0"/>
+                <a:ea typeface="微软雅黑" charset="0"/>
+                <a:cs typeface="微软雅黑" charset="0"/>
+              </a:rPr>
+            </a:br>
+            <a:r>
+              <a:rPr lang="en-US" altLang="zh-CN" sz="1200" b="1">
+                <a:latin typeface="微软雅黑" charset="0"/>
+                <a:ea typeface="微软雅黑" charset="0"/>
+                <a:cs typeface="微软雅黑" charset="0"/>
+              </a:rPr>
+              <a:t>x1</a:t>
+            </a:r>
+            <a:r>
+              <a:rPr lang="zh-CN" altLang="en-US" sz="1200" b="1">
+                <a:latin typeface="微软雅黑" charset="0"/>
+                <a:ea typeface="微软雅黑" charset="0"/>
+                <a:cs typeface="微软雅黑" charset="0"/>
+              </a:rPr>
+              <a:t>在根据第二次前项</a:t>
+            </a:r>
+            <a:r>
+              <a:rPr lang="en-US" altLang="zh-CN" sz="1200" b="1">
+                <a:latin typeface="微软雅黑" charset="0"/>
+                <a:ea typeface="微软雅黑" charset="0"/>
+                <a:cs typeface="微软雅黑" charset="0"/>
+              </a:rPr>
+              <a:t>-</a:t>
+            </a:r>
+            <a:r>
+              <a:rPr lang="zh-CN" altLang="en-US" sz="1200" b="1">
+                <a:latin typeface="微软雅黑" charset="0"/>
+                <a:ea typeface="微软雅黑" charset="0"/>
+                <a:cs typeface="微软雅黑" charset="0"/>
+              </a:rPr>
+              <a:t>反向过程得到</a:t>
+            </a:r>
+            <a:r>
+              <a:rPr lang="en-US" altLang="zh-CN" sz="1200" b="1">
+                <a:latin typeface="微软雅黑" charset="0"/>
+                <a:ea typeface="微软雅黑" charset="0"/>
+                <a:cs typeface="微软雅黑" charset="0"/>
+              </a:rPr>
+              <a:t>y2</a:t>
+            </a:r>
+            <a:r>
+              <a:rPr lang="zh-CN" altLang="en-US" sz="1200" b="1">
+                <a:latin typeface="微软雅黑" charset="0"/>
+                <a:ea typeface="微软雅黑" charset="0"/>
+                <a:cs typeface="微软雅黑" charset="0"/>
+              </a:rPr>
+              <a:t>，</a:t>
+            </a:r>
+            <a:br>
+              <a:rPr lang="zh-CN" altLang="en-US" sz="1200" b="1">
+                <a:latin typeface="微软雅黑" charset="0"/>
+                <a:ea typeface="微软雅黑" charset="0"/>
+                <a:cs typeface="微软雅黑" charset="0"/>
+              </a:rPr>
+            </a:br>
+            <a:r>
+              <a:rPr lang="en-US" altLang="zh-CN" sz="1200" b="1">
+                <a:latin typeface="微软雅黑" charset="0"/>
+                <a:ea typeface="微软雅黑" charset="0"/>
+                <a:cs typeface="微软雅黑" charset="0"/>
+              </a:rPr>
+              <a:t>x1+y2=x3</a:t>
+            </a:r>
+            <a:br>
+              <a:rPr lang="en-US" altLang="zh-CN" sz="1200" b="1">
+                <a:latin typeface="微软雅黑" charset="0"/>
+                <a:ea typeface="微软雅黑" charset="0"/>
+                <a:cs typeface="微软雅黑" charset="0"/>
+              </a:rPr>
+            </a:br>
+            <a:r>
+              <a:rPr lang="zh-CN" altLang="en-US" sz="1200" b="1">
+                <a:latin typeface="微软雅黑" charset="0"/>
+                <a:ea typeface="微软雅黑" charset="0"/>
+                <a:cs typeface="微软雅黑" charset="0"/>
+              </a:rPr>
+              <a:t>如此</a:t>
+            </a:r>
+            <a:r>
+              <a:rPr lang="zh-CN" altLang="en-US" sz="1200" b="1">
+                <a:latin typeface="微软雅黑" charset="0"/>
+                <a:ea typeface="微软雅黑" charset="0"/>
+                <a:cs typeface="微软雅黑" charset="0"/>
+              </a:rPr>
+              <a:t>循环</a:t>
+            </a:r>
+            <a:endParaRPr lang="zh-CN" altLang="en-US" sz="1200" b="1">
+              <a:latin typeface="微软雅黑" charset="0"/>
+              <a:ea typeface="微软雅黑" charset="0"/>
+              <a:cs typeface="微软雅黑" charset="0"/>
+            </a:endParaRPr>
+          </a:p>
+        </p:txBody>
+      </p:sp>
+      <p:sp>
+        <p:nvSpPr>
+          <p:cNvPr id="7" name="文本框 6"/>
+          <p:cNvSpPr txBox="1"/>
+          <p:nvPr>
+            <p:custDataLst>
+              <p:tags r:id="rId7"/>
+            </p:custDataLst>
+          </p:nvPr>
+        </p:nvSpPr>
+        <p:spPr>
+          <a:xfrm>
+            <a:off x="1432560" y="3601085"/>
+            <a:ext cx="8464550" cy="322580"/>
+          </a:xfrm>
+          <a:prstGeom prst="rect">
+            <a:avLst/>
+          </a:prstGeom>
+          <a:noFill/>
+        </p:spPr>
+        <p:txBody>
+          <a:bodyPr wrap="square" rtlCol="0">
+            <a:noAutofit/>
+          </a:bodyPr>
+          <a:p>
+            <a:pPr algn="ctr"/>
+            <a:r>
+              <a:rPr lang="zh-CN" altLang="en-US" sz="2000" b="1">
+                <a:latin typeface="微软雅黑" charset="0"/>
+                <a:ea typeface="微软雅黑" charset="0"/>
+                <a:cs typeface="微软雅黑" charset="0"/>
+              </a:rPr>
+              <a:t>提出了对抗训练，使用对抗样本来训练模型，提高模型鲁棒性</a:t>
+            </a:r>
+            <a:endParaRPr lang="zh-CN" altLang="en-US" sz="2000" b="1">
+              <a:latin typeface="微软雅黑" charset="0"/>
+              <a:ea typeface="微软雅黑" charset="0"/>
+              <a:cs typeface="微软雅黑" charset="0"/>
+            </a:endParaRPr>
+          </a:p>
+        </p:txBody>
+      </p:sp>
+    </p:spTree>
+  </p:cSld>
+  <p:clrMapOvr>
+    <a:masterClrMapping/>
+  </p:clrMapOvr>
+</p:sld>
+</file>
+
+<file path=ppt/tags/tag1.xml><?xml version="1.0" encoding="utf-8"?>
+<p:tagLst xmlns:p="http://schemas.openxmlformats.org/presentationml/2006/main">
+  <p:tag name="KSO_WM_BEAUTIFY_FLAG" val=""/>
+</p:tagLst>
+</file>
+
+<file path=ppt/tags/tag10.xml><?xml version="1.0" encoding="utf-8"?>
+<p:tagLst xmlns:p="http://schemas.openxmlformats.org/presentationml/2006/main">
+  <p:tag name="KSO_WM_BEAUTIFY_FLAG" val=""/>
+</p:tagLst>
+</file>
+
+<file path=ppt/tags/tag11.xml><?xml version="1.0" encoding="utf-8"?>
+<p:tagLst xmlns:p="http://schemas.openxmlformats.org/presentationml/2006/main">
+  <p:tag name="KSO_WM_BEAUTIFY_FLAG" val=""/>
+</p:tagLst>
+</file>
+
+<file path=ppt/tags/tag12.xml><?xml version="1.0" encoding="utf-8"?>
+<p:tagLst xmlns:p="http://schemas.openxmlformats.org/presentationml/2006/main">
+  <p:tag name="KSO_WM_BEAUTIFY_FLAG" val=""/>
+</p:tagLst>
+</file>
+
+<file path=ppt/tags/tag13.xml><?xml version="1.0" encoding="utf-8"?>
+<p:tagLst xmlns:p="http://schemas.openxmlformats.org/presentationml/2006/main">
+  <p:tag name="KSO_WM_BEAUTIFY_FLAG" val=""/>
+</p:tagLst>
+</file>
+
+<file path=ppt/tags/tag14.xml><?xml version="1.0" encoding="utf-8"?>
+<p:tagLst xmlns:p="http://schemas.openxmlformats.org/presentationml/2006/main">
+  <p:tag name="KSO_WM_BEAUTIFY_FLAG" val=""/>
+</p:tagLst>
+</file>
+
+<file path=ppt/tags/tag15.xml><?xml version="1.0" encoding="utf-8"?>
+<p:tagLst xmlns:p="http://schemas.openxmlformats.org/presentationml/2006/main">
+  <p:tag name="KSO_WM_BEAUTIFY_FLAG" val=""/>
+</p:tagLst>
+</file>
+
+<file path=ppt/tags/tag16.xml><?xml version="1.0" encoding="utf-8"?>
+<p:tagLst xmlns:p="http://schemas.openxmlformats.org/presentationml/2006/main">
+  <p:tag name="KSO_WM_BEAUTIFY_FLAG" val=""/>
+</p:tagLst>
+</file>
+
+<file path=ppt/tags/tag17.xml><?xml version="1.0" encoding="utf-8"?>
+<p:tagLst xmlns:p="http://schemas.openxmlformats.org/presentationml/2006/main">
+  <p:tag name="KSO_WM_BEAUTIFY_FLAG" val=""/>
+</p:tagLst>
+</file>
+
+<file path=ppt/tags/tag18.xml><?xml version="1.0" encoding="utf-8"?>
+<p:tagLst xmlns:p="http://schemas.openxmlformats.org/presentationml/2006/main">
+  <p:tag name="KSO_WM_BEAUTIFY_FLAG" val=""/>
+</p:tagLst>
+</file>
+
+<file path=ppt/tags/tag19.xml><?xml version="1.0" encoding="utf-8"?>
+<p:tagLst xmlns:p="http://schemas.openxmlformats.org/presentationml/2006/main">
+  <p:tag name="KSO_WM_BEAUTIFY_FLAG" val=""/>
+</p:tagLst>
+</file>
+
+<file path=ppt/tags/tag2.xml><?xml version="1.0" encoding="utf-8"?>
+<p:tagLst xmlns:p="http://schemas.openxmlformats.org/presentationml/2006/main">
+  <p:tag name="KSO_WM_BEAUTIFY_FLAG" val=""/>
+</p:tagLst>
+</file>
+
+<file path=ppt/tags/tag20.xml><?xml version="1.0" encoding="utf-8"?>
+<p:tagLst xmlns:p="http://schemas.openxmlformats.org/presentationml/2006/main">
+  <p:tag name="KSO_WM_BEAUTIFY_FLAG" val=""/>
+</p:tagLst>
+</file>
+
+<file path=ppt/tags/tag21.xml><?xml version="1.0" encoding="utf-8"?>
+<p:tagLst xmlns:p="http://schemas.openxmlformats.org/presentationml/2006/main">
+  <p:tag name="KSO_WM_BEAUTIFY_FLAG" val=""/>
+</p:tagLst>
+</file>
+
+<file path=ppt/tags/tag22.xml><?xml version="1.0" encoding="utf-8"?>
+<p:tagLst xmlns:p="http://schemas.openxmlformats.org/presentationml/2006/main">
+  <p:tag name="KSO_WM_BEAUTIFY_FLAG" val=""/>
+</p:tagLst>
+</file>
+
+<file path=ppt/tags/tag23.xml><?xml version="1.0" encoding="utf-8"?>
+<p:tagLst xmlns:p="http://schemas.openxmlformats.org/presentationml/2006/main">
+  <p:tag name="KSO_WM_BEAUTIFY_FLAG" val=""/>
+</p:tagLst>
+</file>
+
+<file path=ppt/tags/tag24.xml><?xml version="1.0" encoding="utf-8"?>
+<p:tagLst xmlns:p="http://schemas.openxmlformats.org/presentationml/2006/main">
+  <p:tag name="KSO_WM_BEAUTIFY_FLAG" val=""/>
+</p:tagLst>
+</file>
+
+<file path=ppt/tags/tag25.xml><?xml version="1.0" encoding="utf-8"?>
+<p:tagLst xmlns:p="http://schemas.openxmlformats.org/presentationml/2006/main">
+  <p:tag name="KSO_WM_BEAUTIFY_FLAG" val=""/>
+</p:tagLst>
+</file>
+
+<file path=ppt/tags/tag26.xml><?xml version="1.0" encoding="utf-8"?>
+<p:tagLst xmlns:p="http://schemas.openxmlformats.org/presentationml/2006/main">
+  <p:tag name="KSO_WM_BEAUTIFY_FLAG" val=""/>
+</p:tagLst>
+</file>
+
+<file path=ppt/tags/tag27.xml><?xml version="1.0" encoding="utf-8"?>
+<p:tagLst xmlns:p="http://schemas.openxmlformats.org/presentationml/2006/main">
+  <p:tag name="KSO_WM_BEAUTIFY_FLAG" val=""/>
+</p:tagLst>
+</file>
+
+<file path=ppt/tags/tag28.xml><?xml version="1.0" encoding="utf-8"?>
+<p:tagLst xmlns:p="http://schemas.openxmlformats.org/presentationml/2006/main">
+  <p:tag name="KSO_WM_BEAUTIFY_FLAG" val=""/>
+</p:tagLst>
+</file>
+
+<file path=ppt/tags/tag29.xml><?xml version="1.0" encoding="utf-8"?>
+<p:tagLst xmlns:p="http://schemas.openxmlformats.org/presentationml/2006/main">
+  <p:tag name="KSO_WM_BEAUTIFY_FLAG" val=""/>
+</p:tagLst>
+</file>
+
+<file path=ppt/tags/tag3.xml><?xml version="1.0" encoding="utf-8"?>
+<p:tagLst xmlns:p="http://schemas.openxmlformats.org/presentationml/2006/main">
+  <p:tag name="KSO_WM_BEAUTIFY_FLAG" val=""/>
+</p:tagLst>
+</file>
+
+<file path=ppt/tags/tag30.xml><?xml version="1.0" encoding="utf-8"?>
+<p:tagLst xmlns:p="http://schemas.openxmlformats.org/presentationml/2006/main">
+  <p:tag name="KSO_WM_BEAUTIFY_FLAG" val=""/>
+</p:tagLst>
+</file>
+
+<file path=ppt/tags/tag31.xml><?xml version="1.0" encoding="utf-8"?>
+<p:tagLst xmlns:p="http://schemas.openxmlformats.org/presentationml/2006/main">
+  <p:tag name="KSO_WM_BEAUTIFY_FLAG" val=""/>
+</p:tagLst>
+</file>
+
+<file path=ppt/tags/tag32.xml><?xml version="1.0" encoding="utf-8"?>
+<p:tagLst xmlns:p="http://schemas.openxmlformats.org/presentationml/2006/main">
+  <p:tag name="KSO_WM_BEAUTIFY_FLAG" val=""/>
+</p:tagLst>
+</file>
+
+<file path=ppt/tags/tag33.xml><?xml version="1.0" encoding="utf-8"?>
+<p:tagLst xmlns:p="http://schemas.openxmlformats.org/presentationml/2006/main">
+  <p:tag name="KSO_WM_BEAUTIFY_FLAG" val=""/>
+</p:tagLst>
+</file>
+
+<file path=ppt/tags/tag34.xml><?xml version="1.0" encoding="utf-8"?>
+<p:tagLst xmlns:p="http://schemas.openxmlformats.org/presentationml/2006/main">
+  <p:tag name="KSO_WM_BEAUTIFY_FLAG" val=""/>
+</p:tagLst>
+</file>
+
+<file path=ppt/tags/tag35.xml><?xml version="1.0" encoding="utf-8"?>
+<p:tagLst xmlns:p="http://schemas.openxmlformats.org/presentationml/2006/main">
+  <p:tag name="KSO_WM_BEAUTIFY_FLAG" val=""/>
+</p:tagLst>
+</file>
+
+<file path=ppt/tags/tag36.xml><?xml version="1.0" encoding="utf-8"?>
+<p:tagLst xmlns:p="http://schemas.openxmlformats.org/presentationml/2006/main">
+  <p:tag name="KSO_WM_BEAUTIFY_FLAG" val=""/>
+</p:tagLst>
+</file>
+
+<file path=ppt/tags/tag37.xml><?xml version="1.0" encoding="utf-8"?>
+<p:tagLst xmlns:p="http://schemas.openxmlformats.org/presentationml/2006/main">
+  <p:tag name="KSO_WM_BEAUTIFY_FLAG" val=""/>
+</p:tagLst>
+</file>
+
+<file path=ppt/tags/tag38.xml><?xml version="1.0" encoding="utf-8"?>
+<p:tagLst xmlns:p="http://schemas.openxmlformats.org/presentationml/2006/main">
+  <p:tag name="KSO_WM_BEAUTIFY_FLAG" val=""/>
+</p:tagLst>
+</file>
+
+<file path=ppt/tags/tag39.xml><?xml version="1.0" encoding="utf-8"?>
+<p:tagLst xmlns:p="http://schemas.openxmlformats.org/presentationml/2006/main">
+  <p:tag name="KSO_WM_BEAUTIFY_FLAG" val=""/>
+</p:tagLst>
+</file>
+
+<file path=ppt/tags/tag4.xml><?xml version="1.0" encoding="utf-8"?>
+<p:tagLst xmlns:p="http://schemas.openxmlformats.org/presentationml/2006/main">
+  <p:tag name="KSO_WM_BEAUTIFY_FLAG" val=""/>
+</p:tagLst>
+</file>
+
+<file path=ppt/tags/tag40.xml><?xml version="1.0" encoding="utf-8"?>
+<p:tagLst xmlns:p="http://schemas.openxmlformats.org/presentationml/2006/main">
+  <p:tag name="KSO_WM_BEAUTIFY_FLAG" val=""/>
+</p:tagLst>
+</file>
+
+<file path=ppt/tags/tag41.xml><?xml version="1.0" encoding="utf-8"?>
+<p:tagLst xmlns:p="http://schemas.openxmlformats.org/presentationml/2006/main">
+  <p:tag name="KSO_WM_BEAUTIFY_FLAG" val=""/>
+</p:tagLst>
+</file>
+
+<file path=ppt/tags/tag42.xml><?xml version="1.0" encoding="utf-8"?>
+<p:tagLst xmlns:p="http://schemas.openxmlformats.org/presentationml/2006/main">
+  <p:tag name="KSO_WM_BEAUTIFY_FLAG" val=""/>
+</p:tagLst>
+</file>
+
+<file path=ppt/tags/tag43.xml><?xml version="1.0" encoding="utf-8"?>
+<p:tagLst xmlns:p="http://schemas.openxmlformats.org/presentationml/2006/main">
+  <p:tag name="KSO_WM_BEAUTIFY_FLAG" val=""/>
+</p:tagLst>
+</file>
+
+<file path=ppt/tags/tag44.xml><?xml version="1.0" encoding="utf-8"?>
+<p:tagLst xmlns:p="http://schemas.openxmlformats.org/presentationml/2006/main">
+  <p:tag name="KSO_WM_BEAUTIFY_FLAG" val=""/>
+</p:tagLst>
+</file>
+
+<file path=ppt/tags/tag45.xml><?xml version="1.0" encoding="utf-8"?>
+<p:tagLst xmlns:p="http://schemas.openxmlformats.org/presentationml/2006/main">
+  <p:tag name="KSO_WM_BEAUTIFY_FLAG" val=""/>
+</p:tagLst>
+</file>
+
+<file path=ppt/tags/tag46.xml><?xml version="1.0" encoding="utf-8"?>
+<p:tagLst xmlns:p="http://schemas.openxmlformats.org/presentationml/2006/main">
+  <p:tag name="KSO_WM_BEAUTIFY_FLAG" val=""/>
+</p:tagLst>
+</file>
+
+<file path=ppt/tags/tag47.xml><?xml version="1.0" encoding="utf-8"?>
+<p:tagLst xmlns:p="http://schemas.openxmlformats.org/presentationml/2006/main">
+  <p:tag name="KSO_WM_BEAUTIFY_FLAG" val=""/>
+</p:tagLst>
+</file>
+
+<file path=ppt/tags/tag48.xml><?xml version="1.0" encoding="utf-8"?>
+<p:tagLst xmlns:p="http://schemas.openxmlformats.org/presentationml/2006/main">
+  <p:tag name="KSO_WM_BEAUTIFY_FLAG" val=""/>
+</p:tagLst>
+</file>
+
+<file path=ppt/tags/tag49.xml><?xml version="1.0" encoding="utf-8"?>
+<p:tagLst xmlns:p="http://schemas.openxmlformats.org/presentationml/2006/main">
+  <p:tag name="KSO_WM_BEAUTIFY_FLAG" val=""/>
+</p:tagLst>
+</file>
+
+<file path=ppt/tags/tag5.xml><?xml version="1.0" encoding="utf-8"?>
+<p:tagLst xmlns:p="http://schemas.openxmlformats.org/presentationml/2006/main">
+  <p:tag name="KSO_WM_BEAUTIFY_FLAG" val=""/>
+</p:tagLst>
+</file>
+
+<file path=ppt/tags/tag50.xml><?xml version="1.0" encoding="utf-8"?>
+<p:tagLst xmlns:p="http://schemas.openxmlformats.org/presentationml/2006/main">
+  <p:tag name="KSO_WM_BEAUTIFY_FLAG" val=""/>
+</p:tagLst>
+</file>
+
+<file path=ppt/tags/tag51.xml><?xml version="1.0" encoding="utf-8"?>
+<p:tagLst xmlns:p="http://schemas.openxmlformats.org/presentationml/2006/main">
+  <p:tag name="KSO_WM_BEAUTIFY_FLAG" val=""/>
+</p:tagLst>
+</file>
+
+<file path=ppt/tags/tag52.xml><?xml version="1.0" encoding="utf-8"?>
+<p:tagLst xmlns:p="http://schemas.openxmlformats.org/presentationml/2006/main">
+  <p:tag name="KSO_WM_BEAUTIFY_FLAG" val=""/>
+</p:tagLst>
+</file>
+
+<file path=ppt/tags/tag53.xml><?xml version="1.0" encoding="utf-8"?>
+<p:tagLst xmlns:p="http://schemas.openxmlformats.org/presentationml/2006/main">
+  <p:tag name="KSO_WM_BEAUTIFY_FLAG" val=""/>
+</p:tagLst>
+</file>
+
+<file path=ppt/tags/tag54.xml><?xml version="1.0" encoding="utf-8"?>
+<p:tagLst xmlns:p="http://schemas.openxmlformats.org/presentationml/2006/main">
+  <p:tag name="KSO_WM_BEAUTIFY_FLAG" val=""/>
+</p:tagLst>
+</file>
+
+<file path=ppt/tags/tag55.xml><?xml version="1.0" encoding="utf-8"?>
+<p:tagLst xmlns:p="http://schemas.openxmlformats.org/presentationml/2006/main">
+  <p:tag name="KSO_WM_BEAUTIFY_FLAG" val=""/>
+</p:tagLst>
+</file>
+
+<file path=ppt/tags/tag56.xml><?xml version="1.0" encoding="utf-8"?>
+<p:tagLst xmlns:p="http://schemas.openxmlformats.org/presentationml/2006/main">
+  <p:tag name="KSO_WM_BEAUTIFY_FLAG" val=""/>
+</p:tagLst>
+</file>
+
+<file path=ppt/tags/tag57.xml><?xml version="1.0" encoding="utf-8"?>
+<p:tagLst xmlns:p="http://schemas.openxmlformats.org/presentationml/2006/main">
+  <p:tag name="KSO_WM_BEAUTIFY_FLAG" val=""/>
+</p:tagLst>
+</file>
+
+<file path=ppt/tags/tag58.xml><?xml version="1.0" encoding="utf-8"?>
+<p:tagLst xmlns:p="http://schemas.openxmlformats.org/presentationml/2006/main">
+  <p:tag name="KSO_WM_BEAUTIFY_FLAG" val=""/>
+</p:tagLst>
+</file>
+
+<file path=ppt/tags/tag59.xml><?xml version="1.0" encoding="utf-8"?>
+<p:tagLst xmlns:p="http://schemas.openxmlformats.org/presentationml/2006/main">
+  <p:tag name="KSO_WM_BEAUTIFY_FLAG" val=""/>
+</p:tagLst>
+</file>
+
+<file path=ppt/tags/tag6.xml><?xml version="1.0" encoding="utf-8"?>
+<p:tagLst xmlns:p="http://schemas.openxmlformats.org/presentationml/2006/main">
+  <p:tag name="KSO_WM_BEAUTIFY_FLAG" val=""/>
+</p:tagLst>
+</file>
+
+<file path=ppt/tags/tag60.xml><?xml version="1.0" encoding="utf-8"?>
+<p:tagLst xmlns:p="http://schemas.openxmlformats.org/presentationml/2006/main">
+  <p:tag name="KSO_WM_BEAUTIFY_FLAG" val=""/>
+</p:tagLst>
+</file>
+
+<file path=ppt/tags/tag61.xml><?xml version="1.0" encoding="utf-8"?>
+<p:tagLst xmlns:p="http://schemas.openxmlformats.org/presentationml/2006/main">
+  <p:tag name="KSO_WM_BEAUTIFY_FLAG" val=""/>
+</p:tagLst>
+</file>
+
+<file path=ppt/tags/tag62.xml><?xml version="1.0" encoding="utf-8"?>
+<p:tagLst xmlns:p="http://schemas.openxmlformats.org/presentationml/2006/main">
+  <p:tag name="KSO_WM_BEAUTIFY_FLAG" val=""/>
+</p:tagLst>
+</file>
+
+<file path=ppt/tags/tag63.xml><?xml version="1.0" encoding="utf-8"?>
+<p:tagLst xmlns:p="http://schemas.openxmlformats.org/presentationml/2006/main">
+  <p:tag name="KSO_WM_BEAUTIFY_FLAG" val=""/>
+</p:tagLst>
+</file>
+
+<file path=ppt/tags/tag64.xml><?xml version="1.0" encoding="utf-8"?>
+<p:tagLst xmlns:p="http://schemas.openxmlformats.org/presentationml/2006/main">
+  <p:tag name="KSO_WM_BEAUTIFY_FLAG" val=""/>
+</p:tagLst>
+</file>
+
+<file path=ppt/tags/tag65.xml><?xml version="1.0" encoding="utf-8"?>
+<p:tagLst xmlns:p="http://schemas.openxmlformats.org/presentationml/2006/main">
+  <p:tag name="KSO_WM_BEAUTIFY_FLAG" val=""/>
+</p:tagLst>
+</file>
+
+<file path=ppt/tags/tag7.xml><?xml version="1.0" encoding="utf-8"?>
+<p:tagLst xmlns:p="http://schemas.openxmlformats.org/presentationml/2006/main">
+  <p:tag name="KSO_WM_BEAUTIFY_FLAG" val=""/>
+</p:tagLst>
+</file>
+
+<file path=ppt/tags/tag8.xml><?xml version="1.0" encoding="utf-8"?>
+<p:tagLst xmlns:p="http://schemas.openxmlformats.org/presentationml/2006/main">
+  <p:tag name="KSO_WM_BEAUTIFY_FLAG" val=""/>
+</p:tagLst>
+</file>
+
+<file path=ppt/tags/tag9.xml><?xml version="1.0" encoding="utf-8"?>
+<p:tagLst xmlns:p="http://schemas.openxmlformats.org/presentationml/2006/main">
+  <p:tag name="KSO_WM_BEAUTIFY_FLAG" val=""/>
+</p:tagLst>
 </file>
 
 <file path=ppt/theme/theme1.xml><?xml version="1.0" encoding="utf-8"?>

</xml_diff>